<commit_message>
Update presentation files and improve arrow drawing logic in slide kit
</commit_message>
<xml_diff>
--- a/_presentations/Y9_Python/L2_Selection.pptx
+++ b/_presentations/Y9_Python/L2_Selection.pptx
@@ -129,19 +129,19 @@
   <p:extLst>
     <p:ext uri="{521415D9-36F7-43E2-AB2F-B90AF26B5E84}">
       <p14:sectionLst xmlns:p14="http://schemas.microsoft.com/office/powerpoint/2010/main">
-        <p14:section name="Recap &amp; Recall" id="{470f44fb-7690-27ef-bd02-b5a611f6702f}">
+        <p14:section name="Recap &amp; Recall" id="{6b73a9b8-8c8d-34b3-fdd9-f0bef6f4b340}">
           <p14:sldIdLst>
             <p14:sldId id="256"/>
             <p14:sldId id="257"/>
           </p14:sldIdLst>
         </p14:section>
-        <p14:section name="Title" id="{d7c35103-685a-ea54-fbea-b628eb4c937e}">
+        <p14:section name="Title" id="{db7f0676-109a-7d75-48f6-1384a114cfed}">
           <p14:sldIdLst>
             <p14:sldId id="258"/>
             <p14:sldId id="259"/>
           </p14:sldIdLst>
         </p14:section>
-        <p14:section name="Conditions" id="{3881e176-4ba2-9c90-17a5-ea77f219ff96}">
+        <p14:section name="Conditions" id="{82623005-8d9a-db44-8d67-4d538bdbc542}">
           <p14:sldIdLst>
             <p14:sldId id="260"/>
             <p14:sldId id="261"/>
@@ -150,7 +150,7 @@
             <p14:sldId id="264"/>
           </p14:sldIdLst>
         </p14:section>
-        <p14:section name="Round 1 — numbers" id="{99ac1b39-9823-d392-d133-670a028516b1}">
+        <p14:section name="Round 1 — numbers" id="{0e91583e-7158-72ea-0cea-1e99c6ab6b2e}">
           <p14:sldIdLst>
             <p14:sldId id="265"/>
             <p14:sldId id="266"/>
@@ -158,7 +158,7 @@
             <p14:sldId id="268"/>
           </p14:sldIdLst>
         </p14:section>
-        <p14:section name="Round 2 — a variable" id="{4ca17572-89ee-0bd6-0fff-1d8aea18efda}">
+        <p14:section name="Round 2 — a variable" id="{26454c6e-fe77-5b92-46f3-1cdcc26e51ba}">
           <p14:sldIdLst>
             <p14:sldId id="269"/>
             <p14:sldId id="270"/>
@@ -167,19 +167,19 @@
             <p14:sldId id="273"/>
           </p14:sldIdLst>
         </p14:section>
-        <p14:section name="elif" id="{6826ad9b-ac87-60d8-c521-e01298055002}">
+        <p14:section name="elif" id="{333cf8bc-68b3-28a8-b0ba-0b657768ffc9}">
           <p14:sldIdLst>
             <p14:sldId id="274"/>
             <p14:sldId id="275"/>
           </p14:sldIdLst>
         </p14:section>
-        <p14:section name="Proximity" id="{6fdeae83-9ab0-ed9c-81c8-af5f25378c49}">
+        <p14:section name="Proximity" id="{a003df36-eabf-e0f7-36ae-f4c906b3c851}">
           <p14:sldIdLst>
             <p14:sldId id="276"/>
             <p14:sldId id="277"/>
           </p14:sldIdLst>
         </p14:section>
-        <p14:section name="Plenary" id="{0c8cd85a-3d35-88b8-f9cf-2c64b1a53e29}">
+        <p14:section name="Plenary" id="{7b3ff6fa-a23e-6b29-1456-52605dfa0ab8}">
           <p14:sldIdLst>
             <p14:sldId id="278"/>
           </p14:sldIdLst>
@@ -681,8 +681,8 @@
               <a:rPr lang="en-US" dirty="0"/>
               <a:t>I DO — model it out loud, students just watch. Same three questions every time (the strip at the bottom).
 Click 1 — True or False? "Is 30 more than or equal to 50? No. False."
-Click 2 — Which lines run? "False, so skip the if block and run the else block. Line 5 isn't indented, so it isn't in either block: it runs every time."
-Click 3 — What is printed? Too close, then Scan complete.
+Click 2 — Which lines run? "False, so skip the if block and run the else block."
+Click 3 — What is printed? Too close — and only Too close.
 Say the steps every time: "condition, block, print".</a:t>
             </a:r>
             <a:endParaRPr lang="en-US" dirty="0"/>
@@ -773,8 +773,8 @@
               <a:rPr lang="en-US" dirty="0"/>
               <a:t>WE DO — students answer each step on boards BEFORE you click.
 Step 1: "True or False?" Boards up → click. (== asks "are they equal?" 7 equals 7: True.)
-Step 2: "Which lines run?" Cold-call someone to say the line numbers → click. Line 5 runs every time.
-Step 3: "What is printed?" Boards up → click. Door open, then Done.
+Step 2: "Which lines run?" Cold-call someone to say the line numbers → click.
+Step 3: "What is printed?" Boards up → click. Door open.
 Look for anyone writing Door open AND Door locked: exactly one block runs.</a:t>
             </a:r>
             <a:endParaRPr lang="en-US" dirty="0"/>
@@ -954,8 +954,9 @@
             <a:r>
               <a:rPr lang="en-US" dirty="0"/>
               <a:t>Check boards. Most common mistakes:
-2: "Alarm" — 20 is not MORE than 20, so it's False. And forgetting "Scan done", which runs every time.
-3: "Wait" — &gt;= lets 4 equal 4, so it's True. And forgetting "End".
+2: "Alarm" — 20 is not MORE than 20, so it's False.
+3: "Wait" — &gt;= lets 4 equal 4, so it's True.
+Anyone who wrote both messages for a program: exactly one block runs.
 If most of the class got 2 or 3 wrong, do one more together before Round 2.</a:t>
             </a:r>
             <a:endParaRPr lang="en-US" dirty="0"/>
@@ -1135,12 +1136,12 @@
           <a:p>
             <a:r>
               <a:rPr lang="en-US" dirty="0"/>
-              <a:t>I DO — the same program as Round 1's I do, but the number is now in a variable. One new step: look in the box.
+              <a:t>I DO — Round 1's I do program with two changes: the number is now in a variable (one new step: look in the box), and a last line that isn't indented.
 Click 1 — Look in the box: line 1 stores 30 in distance.
 Click 2 — True or False? "Swap distance for what's in the box: 30 &gt;= 50. False."
-Click 3 — Which lines run? The else block, and line 6 every time.
-Click 4 — What is printed? Same as before: Too close, Scan complete.
-Point out: the output didn't change — a variable is just a name for the value in the box.</a:t>
+Click 3 — Which lines run? "The else block. Line 6 isn't indented, so it isn't inside the if or the else: it runs every time, after them."
+Click 4 — What is printed? Too close, then Scan complete.
+Point out: Too close is the same as Round 1 — a variable is just a name for the value in the box. Scan complete is new, and it would print whatever distance was.</a:t>
             </a:r>
             <a:endParaRPr lang="en-US" dirty="0"/>
           </a:p>
@@ -5725,7 +5726,7 @@
       </p:pic>
       <p:sp>
         <p:nvSpPr>
-          <p:cNvPr id="25" name="Slide Number Placeholder 0"/>
+          <p:cNvPr id="54" name="Slide Number Placeholder 0"/>
           <p:cNvSpPr>
             <a:spLocks noGrp="1"/>
           </p:cNvSpPr>
@@ -5923,11 +5924,11 @@
         <p:spPr>
           <a:xfrm>
             <a:off x="548640" y="1554480"/>
-            <a:ext cx="4846320" cy="3236976"/>
+            <a:ext cx="4846320" cy="3328416"/>
           </a:xfrm>
           <a:prstGeom prst="roundRect">
             <a:avLst>
-              <a:gd name="adj" fmla="val 2260"/>
+              <a:gd name="adj" fmla="val 2198"/>
             </a:avLst>
           </a:prstGeom>
           <a:solidFill>
@@ -5950,7 +5951,7 @@
         <p:spPr>
           <a:xfrm>
             <a:off x="658368" y="1755648"/>
-            <a:ext cx="274320" cy="566928"/>
+            <a:ext cx="274320" cy="731520"/>
           </a:xfrm>
           <a:prstGeom prst="rect">
             <a:avLst/>
@@ -5989,7 +5990,7 @@
         <p:spPr>
           <a:xfrm>
             <a:off x="1188720" y="1755648"/>
-            <a:ext cx="4114800" cy="566928"/>
+            <a:ext cx="4114800" cy="731520"/>
           </a:xfrm>
           <a:prstGeom prst="rect">
             <a:avLst/>
@@ -6125,8 +6126,8 @@
         </p:nvSpPr>
         <p:spPr>
           <a:xfrm>
-            <a:off x="658368" y="2322576"/>
-            <a:ext cx="274320" cy="566928"/>
+            <a:off x="658368" y="2487168"/>
+            <a:ext cx="274320" cy="731520"/>
           </a:xfrm>
           <a:prstGeom prst="rect">
             <a:avLst/>
@@ -6164,8 +6165,8 @@
         </p:nvSpPr>
         <p:spPr>
           <a:xfrm>
-            <a:off x="1188720" y="2322576"/>
-            <a:ext cx="4114800" cy="566928"/>
+            <a:off x="1188720" y="2487168"/>
+            <a:ext cx="4114800" cy="731520"/>
           </a:xfrm>
           <a:prstGeom prst="rect">
             <a:avLst/>
@@ -6259,8 +6260,8 @@
         </p:nvSpPr>
         <p:spPr>
           <a:xfrm>
-            <a:off x="658368" y="2889504"/>
-            <a:ext cx="274320" cy="566928"/>
+            <a:off x="658368" y="3218688"/>
+            <a:ext cx="274320" cy="731520"/>
           </a:xfrm>
           <a:prstGeom prst="rect">
             <a:avLst/>
@@ -6298,8 +6299,8 @@
         </p:nvSpPr>
         <p:spPr>
           <a:xfrm>
-            <a:off x="1188720" y="2889504"/>
-            <a:ext cx="4114800" cy="566928"/>
+            <a:off x="1188720" y="3218688"/>
+            <a:ext cx="4114800" cy="731520"/>
           </a:xfrm>
           <a:prstGeom prst="rect">
             <a:avLst/>
@@ -6351,8 +6352,8 @@
         </p:nvSpPr>
         <p:spPr>
           <a:xfrm>
-            <a:off x="658368" y="3456432"/>
-            <a:ext cx="274320" cy="566928"/>
+            <a:off x="658368" y="3950208"/>
+            <a:ext cx="274320" cy="731520"/>
           </a:xfrm>
           <a:prstGeom prst="rect">
             <a:avLst/>
@@ -6390,8 +6391,8 @@
         </p:nvSpPr>
         <p:spPr>
           <a:xfrm>
-            <a:off x="1188720" y="3456432"/>
-            <a:ext cx="4114800" cy="566928"/>
+            <a:off x="1188720" y="3950208"/>
+            <a:ext cx="4114800" cy="731520"/>
           </a:xfrm>
           <a:prstGeom prst="rect">
             <a:avLst/>
@@ -6479,133 +6480,13 @@
       </p:sp>
       <p:sp>
         <p:nvSpPr>
-          <p:cNvPr id="14" name="Text 11"/>
-          <p:cNvSpPr txBox="1"/>
-          <p:nvPr/>
-        </p:nvSpPr>
-        <p:spPr>
-          <a:xfrm>
-            <a:off x="658368" y="4023360"/>
-            <a:ext cx="274320" cy="566928"/>
-          </a:xfrm>
-          <a:prstGeom prst="rect">
-            <a:avLst/>
-          </a:prstGeom>
-          <a:noFill/>
-          <a:ln/>
-        </p:spPr>
-        <p:txBody>
-          <a:bodyPr wrap="square" lIns="0" tIns="0" rIns="0" bIns="0" rtlCol="0" anchor="ctr"/>
-          <a:lstStyle/>
-          <a:p>
-            <a:pPr algn="r" indent="0" marL="0">
-              <a:buNone/>
-            </a:pPr>
-            <a:r>
-              <a:rPr lang="en-US" sz="2000" dirty="0">
-                <a:solidFill>
-                  <a:srgbClr val="6E6E7A"/>
-                </a:solidFill>
-                <a:latin typeface="Consolas" pitchFamily="34" charset="0"/>
-                <a:ea typeface="Consolas" pitchFamily="34" charset="-122"/>
-                <a:cs typeface="Consolas" pitchFamily="34" charset="-120"/>
-              </a:rPr>
-              <a:t>5</a:t>
-            </a:r>
-            <a:endParaRPr lang="en-US" sz="2000" dirty="0"/>
-          </a:p>
-        </p:txBody>
-      </p:sp>
-      <p:sp>
-        <p:nvSpPr>
-          <p:cNvPr id="15" name="Text 12"/>
-          <p:cNvSpPr txBox="1"/>
-          <p:nvPr/>
-        </p:nvSpPr>
-        <p:spPr>
-          <a:xfrm>
-            <a:off x="1188720" y="4023360"/>
-            <a:ext cx="4114800" cy="566928"/>
-          </a:xfrm>
-          <a:prstGeom prst="rect">
-            <a:avLst/>
-          </a:prstGeom>
-          <a:noFill/>
-          <a:ln/>
-        </p:spPr>
-        <p:txBody>
-          <a:bodyPr wrap="square" lIns="0" tIns="0" rIns="0" bIns="0" rtlCol="0" anchor="ctr"/>
-          <a:lstStyle/>
-          <a:p>
-            <a:pPr indent="0" marL="0">
-              <a:buNone/>
-            </a:pPr>
-            <a:r>
-              <a:rPr lang="en-US" sz="2400" dirty="0">
-                <a:solidFill>
-                  <a:srgbClr val="E8C878"/>
-                </a:solidFill>
-                <a:latin typeface="Consolas" pitchFamily="34" charset="0"/>
-                <a:ea typeface="Consolas" pitchFamily="34" charset="-122"/>
-                <a:cs typeface="Consolas" pitchFamily="34" charset="-120"/>
-              </a:rPr>
-              <a:t>print</a:t>
-            </a:r>
-            <a:pPr indent="0" marL="0">
-              <a:buNone/>
-            </a:pPr>
-            <a:r>
-              <a:rPr lang="en-US" sz="2400" dirty="0">
-                <a:solidFill>
-                  <a:srgbClr val="A9A9B4"/>
-                </a:solidFill>
-                <a:latin typeface="Consolas" pitchFamily="34" charset="0"/>
-                <a:ea typeface="Consolas" pitchFamily="34" charset="-122"/>
-                <a:cs typeface="Consolas" pitchFamily="34" charset="-120"/>
-              </a:rPr>
-              <a:t>(</a:t>
-            </a:r>
-            <a:pPr indent="0" marL="0">
-              <a:buNone/>
-            </a:pPr>
-            <a:r>
-              <a:rPr lang="en-US" sz="2400" dirty="0">
-                <a:solidFill>
-                  <a:srgbClr val="E69F00"/>
-                </a:solidFill>
-                <a:latin typeface="Consolas" pitchFamily="34" charset="0"/>
-                <a:ea typeface="Consolas" pitchFamily="34" charset="-122"/>
-                <a:cs typeface="Consolas" pitchFamily="34" charset="-120"/>
-              </a:rPr>
-              <a:t>"Scan complete"</a:t>
-            </a:r>
-            <a:pPr indent="0" marL="0">
-              <a:buNone/>
-            </a:pPr>
-            <a:r>
-              <a:rPr lang="en-US" sz="2400" dirty="0">
-                <a:solidFill>
-                  <a:srgbClr val="A9A9B4"/>
-                </a:solidFill>
-                <a:latin typeface="Consolas" pitchFamily="34" charset="0"/>
-                <a:ea typeface="Consolas" pitchFamily="34" charset="-122"/>
-                <a:cs typeface="Consolas" pitchFamily="34" charset="-120"/>
-              </a:rPr>
-              <a:t>)</a:t>
-            </a:r>
-            <a:endParaRPr lang="en-US" sz="2400" dirty="0"/>
-          </a:p>
-        </p:txBody>
-      </p:sp>
-      <p:sp>
-        <p:nvSpPr>
-          <p:cNvPr id="16" name="click1"/>
+          <p:cNvPr id="14" name="click1"/>
           <p:cNvSpPr/>
           <p:nvPr/>
         </p:nvSpPr>
         <p:spPr>
           <a:xfrm>
-            <a:off x="5623560" y="1874520"/>
+            <a:off x="5623560" y="1956816"/>
             <a:ext cx="329184" cy="329184"/>
           </a:xfrm>
           <a:prstGeom prst="ellipse">
@@ -6619,13 +6500,13 @@
       </p:sp>
       <p:sp>
         <p:nvSpPr>
-          <p:cNvPr id="17" name="click1"/>
-          <p:cNvSpPr txBox="1"/>
-          <p:nvPr/>
-        </p:nvSpPr>
-        <p:spPr>
-          <a:xfrm>
-            <a:off x="5623560" y="1874520"/>
+          <p:cNvPr id="15" name="click1"/>
+          <p:cNvSpPr txBox="1"/>
+          <p:nvPr/>
+        </p:nvSpPr>
+        <p:spPr>
+          <a:xfrm>
+            <a:off x="5623560" y="1956816"/>
             <a:ext cx="329184" cy="329184"/>
           </a:xfrm>
           <a:prstGeom prst="rect">
@@ -6658,14 +6539,14 @@
       </p:sp>
       <p:sp>
         <p:nvSpPr>
-          <p:cNvPr id="18" name="click1"/>
+          <p:cNvPr id="16" name="click1"/>
           <p:cNvSpPr txBox="1"/>
           <p:nvPr/>
         </p:nvSpPr>
         <p:spPr>
           <a:xfrm>
             <a:off x="6053328" y="1755648"/>
-            <a:ext cx="1417320" cy="566928"/>
+            <a:ext cx="1417320" cy="731520"/>
           </a:xfrm>
           <a:prstGeom prst="rect">
             <a:avLst/>
@@ -6753,13 +6634,13 @@
       </p:sp>
       <p:sp>
         <p:nvSpPr>
-          <p:cNvPr id="19" name="click1"/>
+          <p:cNvPr id="17" name="click1"/>
           <p:cNvSpPr/>
           <p:nvPr/>
         </p:nvSpPr>
         <p:spPr>
           <a:xfrm>
-            <a:off x="7516368" y="2039112"/>
+            <a:off x="7516368" y="2121408"/>
             <a:ext cx="365760" cy="0"/>
           </a:xfrm>
           <a:prstGeom prst="line">
@@ -6777,18 +6658,18 @@
       </p:sp>
       <p:sp>
         <p:nvSpPr>
-          <p:cNvPr id="20" name="click1"/>
+          <p:cNvPr id="18" name="click1"/>
           <p:cNvSpPr/>
           <p:nvPr/>
         </p:nvSpPr>
         <p:spPr>
           <a:xfrm>
             <a:off x="7973568" y="1819656"/>
-            <a:ext cx="868680" cy="438912"/>
+            <a:ext cx="868680" cy="603504"/>
           </a:xfrm>
           <a:prstGeom prst="roundRect">
             <a:avLst>
-              <a:gd name="adj" fmla="val 16667"/>
+              <a:gd name="adj" fmla="val 12121"/>
             </a:avLst>
           </a:prstGeom>
           <a:solidFill>
@@ -6804,14 +6685,14 @@
       </p:sp>
       <p:sp>
         <p:nvSpPr>
-          <p:cNvPr id="21" name="click1"/>
+          <p:cNvPr id="19" name="click1"/>
           <p:cNvSpPr txBox="1"/>
           <p:nvPr/>
         </p:nvSpPr>
         <p:spPr>
           <a:xfrm>
             <a:off x="7973568" y="1819656"/>
-            <a:ext cx="868680" cy="438912"/>
+            <a:ext cx="868680" cy="603504"/>
           </a:xfrm>
           <a:prstGeom prst="rect">
             <a:avLst/>
@@ -6843,13 +6724,13 @@
       </p:sp>
       <p:sp>
         <p:nvSpPr>
-          <p:cNvPr id="22" name="click2"/>
+          <p:cNvPr id="20" name="click2"/>
           <p:cNvSpPr/>
           <p:nvPr/>
         </p:nvSpPr>
         <p:spPr>
           <a:xfrm>
-            <a:off x="5623560" y="2441448"/>
+            <a:off x="5623560" y="2688336"/>
             <a:ext cx="329184" cy="329184"/>
           </a:xfrm>
           <a:prstGeom prst="ellipse">
@@ -6863,13 +6744,13 @@
       </p:sp>
       <p:sp>
         <p:nvSpPr>
-          <p:cNvPr id="23" name="click2"/>
-          <p:cNvSpPr txBox="1"/>
-          <p:nvPr/>
-        </p:nvSpPr>
-        <p:spPr>
-          <a:xfrm>
-            <a:off x="5623560" y="2441448"/>
+          <p:cNvPr id="21" name="click2"/>
+          <p:cNvSpPr txBox="1"/>
+          <p:nvPr/>
+        </p:nvSpPr>
+        <p:spPr>
+          <a:xfrm>
+            <a:off x="5623560" y="2688336"/>
             <a:ext cx="329184" cy="329184"/>
           </a:xfrm>
           <a:prstGeom prst="rect">
@@ -6902,14 +6783,14 @@
       </p:sp>
       <p:sp>
         <p:nvSpPr>
-          <p:cNvPr id="24" name="click2"/>
-          <p:cNvSpPr txBox="1"/>
-          <p:nvPr/>
-        </p:nvSpPr>
-        <p:spPr>
-          <a:xfrm>
-            <a:off x="6053328" y="3456432"/>
-            <a:ext cx="2651760" cy="566928"/>
+          <p:cNvPr id="22" name="click2"/>
+          <p:cNvSpPr txBox="1"/>
+          <p:nvPr/>
+        </p:nvSpPr>
+        <p:spPr>
+          <a:xfrm>
+            <a:off x="6053328" y="3950208"/>
+            <a:ext cx="2651760" cy="731520"/>
           </a:xfrm>
           <a:prstGeom prst="rect">
             <a:avLst/>
@@ -6941,14 +6822,14 @@
       </p:sp>
       <p:sp>
         <p:nvSpPr>
-          <p:cNvPr id="25" name="click2"/>
-          <p:cNvSpPr txBox="1"/>
-          <p:nvPr/>
-        </p:nvSpPr>
-        <p:spPr>
-          <a:xfrm>
-            <a:off x="6053328" y="2322576"/>
-            <a:ext cx="2651760" cy="566928"/>
+          <p:cNvPr id="23" name="click2"/>
+          <p:cNvSpPr txBox="1"/>
+          <p:nvPr/>
+        </p:nvSpPr>
+        <p:spPr>
+          <a:xfrm>
+            <a:off x="6053328" y="2487168"/>
+            <a:ext cx="2651760" cy="731520"/>
           </a:xfrm>
           <a:prstGeom prst="rect">
             <a:avLst/>
@@ -6980,155 +6861,116 @@
       </p:sp>
       <p:sp>
         <p:nvSpPr>
-          <p:cNvPr id="26" name="click2"/>
-          <p:cNvSpPr txBox="1"/>
-          <p:nvPr/>
-        </p:nvSpPr>
-        <p:spPr>
-          <a:xfrm>
-            <a:off x="6053328" y="4023360"/>
-            <a:ext cx="2651760" cy="566928"/>
-          </a:xfrm>
-          <a:prstGeom prst="rect">
-            <a:avLst/>
-          </a:prstGeom>
-          <a:noFill/>
-          <a:ln/>
-        </p:spPr>
-        <p:txBody>
-          <a:bodyPr wrap="square" lIns="0" tIns="0" rIns="0" bIns="0" rtlCol="0" anchor="ctr"/>
-          <a:lstStyle/>
-          <a:p>
-            <a:pPr indent="0" marL="0">
-              <a:buNone/>
-            </a:pPr>
-            <a:r>
-              <a:rPr lang="en-US" sz="2000" b="1" dirty="0">
-                <a:solidFill>
-                  <a:srgbClr val="D8A73D"/>
+          <p:cNvPr id="24" name="click3"/>
+          <p:cNvSpPr/>
+          <p:nvPr/>
+        </p:nvSpPr>
+        <p:spPr>
+          <a:xfrm>
+            <a:off x="9098280" y="1554480"/>
+            <a:ext cx="329184" cy="329184"/>
+          </a:xfrm>
+          <a:prstGeom prst="ellipse">
+            <a:avLst/>
+          </a:prstGeom>
+          <a:solidFill>
+            <a:srgbClr val="D8A73D"/>
+          </a:solidFill>
+          <a:ln/>
+        </p:spPr>
+      </p:sp>
+      <p:sp>
+        <p:nvSpPr>
+          <p:cNvPr id="25" name="click3"/>
+          <p:cNvSpPr txBox="1"/>
+          <p:nvPr/>
+        </p:nvSpPr>
+        <p:spPr>
+          <a:xfrm>
+            <a:off x="9098280" y="1554480"/>
+            <a:ext cx="329184" cy="329184"/>
+          </a:xfrm>
+          <a:prstGeom prst="rect">
+            <a:avLst/>
+          </a:prstGeom>
+          <a:noFill/>
+          <a:ln/>
+        </p:spPr>
+        <p:txBody>
+          <a:bodyPr wrap="square" lIns="0" tIns="0" rIns="0" bIns="0" rtlCol="0" anchor="ctr"/>
+          <a:lstStyle/>
+          <a:p>
+            <a:pPr algn="ctr" indent="0" marL="0">
+              <a:buNone/>
+            </a:pPr>
+            <a:r>
+              <a:rPr lang="en-US" sz="1600" b="1" dirty="0">
+                <a:solidFill>
+                  <a:srgbClr val="1E1E24"/>
+                </a:solidFill>
+                <a:latin typeface="Cambria" pitchFamily="34" charset="0"/>
+                <a:ea typeface="Cambria" pitchFamily="34" charset="-122"/>
+                <a:cs typeface="Cambria" pitchFamily="34" charset="-120"/>
+              </a:rPr>
+              <a:t>3</a:t>
+            </a:r>
+            <a:endParaRPr lang="en-US" sz="1600" dirty="0"/>
+          </a:p>
+        </p:txBody>
+      </p:sp>
+      <p:sp>
+        <p:nvSpPr>
+          <p:cNvPr id="26" name="click3"/>
+          <p:cNvSpPr txBox="1"/>
+          <p:nvPr/>
+        </p:nvSpPr>
+        <p:spPr>
+          <a:xfrm>
+            <a:off x="9555480" y="1554480"/>
+            <a:ext cx="2084832" cy="329184"/>
+          </a:xfrm>
+          <a:prstGeom prst="rect">
+            <a:avLst/>
+          </a:prstGeom>
+          <a:noFill/>
+          <a:ln/>
+        </p:spPr>
+        <p:txBody>
+          <a:bodyPr wrap="square" lIns="0" tIns="0" rIns="0" bIns="0" rtlCol="0" anchor="ctr"/>
+          <a:lstStyle/>
+          <a:p>
+            <a:pPr indent="0" marL="0">
+              <a:buNone/>
+            </a:pPr>
+            <a:r>
+              <a:rPr lang="en-US" sz="1300" b="1" spc="200" kern="0" dirty="0">
+                <a:solidFill>
+                  <a:srgbClr val="6E6E7A"/>
                 </a:solidFill>
                 <a:latin typeface="Calibri" pitchFamily="34" charset="0"/>
                 <a:ea typeface="Calibri" pitchFamily="34" charset="-122"/>
                 <a:cs typeface="Calibri" pitchFamily="34" charset="-120"/>
               </a:rPr>
-              <a:t>✓ runs every time</a:t>
-            </a:r>
-            <a:endParaRPr lang="en-US" sz="2000" dirty="0"/>
-          </a:p>
-        </p:txBody>
-      </p:sp>
-      <p:sp>
-        <p:nvSpPr>
-          <p:cNvPr id="27" name="click3"/>
+              <a:t>WHAT IS PRINTED</a:t>
+            </a:r>
+            <a:endParaRPr lang="en-US" sz="1300" dirty="0"/>
+          </a:p>
+        </p:txBody>
+      </p:sp>
+      <p:sp>
+        <p:nvSpPr>
+          <p:cNvPr id="27" name="click3 · terminal"/>
           <p:cNvSpPr/>
           <p:nvPr/>
         </p:nvSpPr>
         <p:spPr>
           <a:xfrm>
-            <a:off x="9098280" y="1554480"/>
-            <a:ext cx="329184" cy="329184"/>
-          </a:xfrm>
-          <a:prstGeom prst="ellipse">
-            <a:avLst/>
-          </a:prstGeom>
-          <a:solidFill>
-            <a:srgbClr val="D8A73D"/>
-          </a:solidFill>
-          <a:ln/>
-        </p:spPr>
-      </p:sp>
-      <p:sp>
-        <p:nvSpPr>
-          <p:cNvPr id="28" name="click3"/>
-          <p:cNvSpPr txBox="1"/>
-          <p:nvPr/>
-        </p:nvSpPr>
-        <p:spPr>
-          <a:xfrm>
-            <a:off x="9098280" y="1554480"/>
-            <a:ext cx="329184" cy="329184"/>
-          </a:xfrm>
-          <a:prstGeom prst="rect">
-            <a:avLst/>
-          </a:prstGeom>
-          <a:noFill/>
-          <a:ln/>
-        </p:spPr>
-        <p:txBody>
-          <a:bodyPr wrap="square" lIns="0" tIns="0" rIns="0" bIns="0" rtlCol="0" anchor="ctr"/>
-          <a:lstStyle/>
-          <a:p>
-            <a:pPr algn="ctr" indent="0" marL="0">
-              <a:buNone/>
-            </a:pPr>
-            <a:r>
-              <a:rPr lang="en-US" sz="1600" b="1" dirty="0">
-                <a:solidFill>
-                  <a:srgbClr val="1E1E24"/>
-                </a:solidFill>
-                <a:latin typeface="Cambria" pitchFamily="34" charset="0"/>
-                <a:ea typeface="Cambria" pitchFamily="34" charset="-122"/>
-                <a:cs typeface="Cambria" pitchFamily="34" charset="-120"/>
-              </a:rPr>
-              <a:t>3</a:t>
-            </a:r>
-            <a:endParaRPr lang="en-US" sz="1600" dirty="0"/>
-          </a:p>
-        </p:txBody>
-      </p:sp>
-      <p:sp>
-        <p:nvSpPr>
-          <p:cNvPr id="29" name="click3"/>
-          <p:cNvSpPr txBox="1"/>
-          <p:nvPr/>
-        </p:nvSpPr>
-        <p:spPr>
-          <a:xfrm>
-            <a:off x="9555480" y="1554480"/>
-            <a:ext cx="2084832" cy="329184"/>
-          </a:xfrm>
-          <a:prstGeom prst="rect">
-            <a:avLst/>
-          </a:prstGeom>
-          <a:noFill/>
-          <a:ln/>
-        </p:spPr>
-        <p:txBody>
-          <a:bodyPr wrap="square" lIns="0" tIns="0" rIns="0" bIns="0" rtlCol="0" anchor="ctr"/>
-          <a:lstStyle/>
-          <a:p>
-            <a:pPr indent="0" marL="0">
-              <a:buNone/>
-            </a:pPr>
-            <a:r>
-              <a:rPr lang="en-US" sz="1300" b="1" spc="200" kern="0" dirty="0">
-                <a:solidFill>
-                  <a:srgbClr val="6E6E7A"/>
-                </a:solidFill>
-                <a:latin typeface="Calibri" pitchFamily="34" charset="0"/>
-                <a:ea typeface="Calibri" pitchFamily="34" charset="-122"/>
-                <a:cs typeface="Calibri" pitchFamily="34" charset="-120"/>
-              </a:rPr>
-              <a:t>WHAT IS PRINTED</a:t>
-            </a:r>
-            <a:endParaRPr lang="en-US" sz="1300" dirty="0"/>
-          </a:p>
-        </p:txBody>
-      </p:sp>
-      <p:sp>
-        <p:nvSpPr>
-          <p:cNvPr id="30" name="click3 · terminal"/>
-          <p:cNvSpPr/>
-          <p:nvPr/>
-        </p:nvSpPr>
-        <p:spPr>
-          <a:xfrm>
             <a:off x="9098280" y="2011680"/>
-            <a:ext cx="2542032" cy="1270000"/>
+            <a:ext cx="2542032" cy="863600"/>
           </a:xfrm>
           <a:prstGeom prst="roundRect">
             <a:avLst>
-              <a:gd name="adj" fmla="val 5760"/>
+              <a:gd name="adj" fmla="val 8471"/>
             </a:avLst>
           </a:prstGeom>
           <a:solidFill>
@@ -7144,7 +6986,7 @@
       </p:sp>
       <p:sp>
         <p:nvSpPr>
-          <p:cNvPr id="31" name="click3"/>
+          <p:cNvPr id="28" name="click3"/>
           <p:cNvSpPr txBox="1"/>
           <p:nvPr/>
         </p:nvSpPr>
@@ -7183,46 +7025,7 @@
       </p:sp>
       <p:sp>
         <p:nvSpPr>
-          <p:cNvPr id="32" name="click3"/>
-          <p:cNvSpPr txBox="1"/>
-          <p:nvPr/>
-        </p:nvSpPr>
-        <p:spPr>
-          <a:xfrm>
-            <a:off x="9326880" y="2646680"/>
-            <a:ext cx="2084832" cy="406400"/>
-          </a:xfrm>
-          <a:prstGeom prst="rect">
-            <a:avLst/>
-          </a:prstGeom>
-          <a:noFill/>
-          <a:ln/>
-        </p:spPr>
-        <p:txBody>
-          <a:bodyPr wrap="square" lIns="0" tIns="0" rIns="0" bIns="0" rtlCol="0" anchor="ctr"/>
-          <a:lstStyle/>
-          <a:p>
-            <a:pPr indent="0" marL="0">
-              <a:buNone/>
-            </a:pPr>
-            <a:r>
-              <a:rPr lang="en-US" sz="2000" dirty="0">
-                <a:solidFill>
-                  <a:srgbClr val="F5F5F3"/>
-                </a:solidFill>
-                <a:latin typeface="Consolas" pitchFamily="34" charset="0"/>
-                <a:ea typeface="Consolas" pitchFamily="34" charset="-122"/>
-                <a:cs typeface="Consolas" pitchFamily="34" charset="-120"/>
-              </a:rPr>
-              <a:t>Scan complete</a:t>
-            </a:r>
-            <a:endParaRPr lang="en-US" sz="2000" dirty="0"/>
-          </a:p>
-        </p:txBody>
-      </p:sp>
-      <p:sp>
-        <p:nvSpPr>
-          <p:cNvPr id="33" name="Shape 30"/>
+          <p:cNvPr id="29" name="Shape 26"/>
           <p:cNvSpPr/>
           <p:nvPr/>
         </p:nvSpPr>
@@ -7244,7 +7047,7 @@
       </p:sp>
       <p:sp>
         <p:nvSpPr>
-          <p:cNvPr id="34" name="Shape 31"/>
+          <p:cNvPr id="30" name="Shape 27"/>
           <p:cNvSpPr/>
           <p:nvPr/>
         </p:nvSpPr>
@@ -7264,7 +7067,7 @@
       </p:sp>
       <p:sp>
         <p:nvSpPr>
-          <p:cNvPr id="35" name="Text 32"/>
+          <p:cNvPr id="31" name="Text 28"/>
           <p:cNvSpPr txBox="1"/>
           <p:nvPr/>
         </p:nvSpPr>
@@ -7303,7 +7106,7 @@
       </p:sp>
       <p:sp>
         <p:nvSpPr>
-          <p:cNvPr id="36" name="Text 33"/>
+          <p:cNvPr id="32" name="Text 29"/>
           <p:cNvSpPr txBox="1"/>
           <p:nvPr/>
         </p:nvSpPr>
@@ -7342,7 +7145,7 @@
       </p:sp>
       <p:sp>
         <p:nvSpPr>
-          <p:cNvPr id="37" name="Shape 34"/>
+          <p:cNvPr id="33" name="Shape 30"/>
           <p:cNvSpPr/>
           <p:nvPr/>
         </p:nvSpPr>
@@ -7362,7 +7165,7 @@
       </p:sp>
       <p:sp>
         <p:nvSpPr>
-          <p:cNvPr id="38" name="Text 35"/>
+          <p:cNvPr id="34" name="Text 31"/>
           <p:cNvSpPr txBox="1"/>
           <p:nvPr/>
         </p:nvSpPr>
@@ -7401,7 +7204,7 @@
       </p:sp>
       <p:sp>
         <p:nvSpPr>
-          <p:cNvPr id="39" name="Text 36"/>
+          <p:cNvPr id="35" name="Text 32"/>
           <p:cNvSpPr txBox="1"/>
           <p:nvPr/>
         </p:nvSpPr>
@@ -7440,7 +7243,7 @@
       </p:sp>
       <p:sp>
         <p:nvSpPr>
-          <p:cNvPr id="40" name="Shape 37"/>
+          <p:cNvPr id="36" name="Shape 33"/>
           <p:cNvSpPr/>
           <p:nvPr/>
         </p:nvSpPr>
@@ -7460,7 +7263,7 @@
       </p:sp>
       <p:sp>
         <p:nvSpPr>
-          <p:cNvPr id="41" name="Text 38"/>
+          <p:cNvPr id="37" name="Text 34"/>
           <p:cNvSpPr txBox="1"/>
           <p:nvPr/>
         </p:nvSpPr>
@@ -7499,7 +7302,7 @@
       </p:sp>
       <p:sp>
         <p:nvSpPr>
-          <p:cNvPr id="42" name="Text 39"/>
+          <p:cNvPr id="38" name="Text 35"/>
           <p:cNvSpPr txBox="1"/>
           <p:nvPr/>
         </p:nvSpPr>
@@ -7538,7 +7341,7 @@
       </p:sp>
       <p:sp>
         <p:nvSpPr>
-          <p:cNvPr id="43" name="Shape 40"/>
+          <p:cNvPr id="39" name="Shape 36"/>
           <p:cNvSpPr/>
           <p:nvPr/>
         </p:nvSpPr>
@@ -7560,7 +7363,7 @@
       </p:sp>
       <p:sp>
         <p:nvSpPr>
-          <p:cNvPr id="44" name="Text 41"/>
+          <p:cNvPr id="40" name="Text 37"/>
           <p:cNvSpPr txBox="1"/>
           <p:nvPr/>
         </p:nvSpPr>
@@ -7599,7 +7402,7 @@
       </p:sp>
       <p:pic>
         <p:nvPicPr>
-          <p:cNvPr id="45" name="Image 1" descr="New information">    </p:cNvPr>
+          <p:cNvPr id="41" name="Image 1" descr="New information">    </p:cNvPr>
           <p:cNvPicPr>
             <a:picLocks noChangeAspect="1"/>
           </p:cNvPicPr>
@@ -7623,7 +7426,7 @@
       </p:pic>
       <p:sp>
         <p:nvSpPr>
-          <p:cNvPr id="25" name="Slide Number Placeholder 0"/>
+          <p:cNvPr id="42" name="Slide Number Placeholder 0"/>
           <p:cNvSpPr>
             <a:spLocks noGrp="1"/>
           </p:cNvSpPr>
@@ -7708,7 +7511,7 @@
                                           </p:stCondLst>
                                         </p:cTn>
                                         <p:tgtEl>
-                                          <p:spTgt spid="16"/>
+                                          <p:spTgt spid="14"/>
                                         </p:tgtEl>
                                         <p:attrNameLst>
                                           <p:attrName>style.visibility</p:attrName>
@@ -7722,7 +7525,7 @@
                                       <p:cBhvr>
                                         <p:cTn id="7" dur="500"/>
                                         <p:tgtEl>
-                                          <p:spTgt spid="16"/>
+                                          <p:spTgt spid="14"/>
                                         </p:tgtEl>
                                       </p:cBhvr>
                                     </p:animEffect>
@@ -7743,7 +7546,7 @@
                                           </p:stCondLst>
                                         </p:cTn>
                                         <p:tgtEl>
-                                          <p:spTgt spid="17"/>
+                                          <p:spTgt spid="15"/>
                                         </p:tgtEl>
                                         <p:attrNameLst>
                                           <p:attrName>style.visibility</p:attrName>
@@ -7757,7 +7560,7 @@
                                       <p:cBhvr>
                                         <p:cTn id="10" dur="500"/>
                                         <p:tgtEl>
-                                          <p:spTgt spid="17"/>
+                                          <p:spTgt spid="15"/>
                                         </p:tgtEl>
                                       </p:cBhvr>
                                     </p:animEffect>
@@ -7778,7 +7581,7 @@
                                           </p:stCondLst>
                                         </p:cTn>
                                         <p:tgtEl>
-                                          <p:spTgt spid="18"/>
+                                          <p:spTgt spid="16"/>
                                         </p:tgtEl>
                                         <p:attrNameLst>
                                           <p:attrName>style.visibility</p:attrName>
@@ -7792,7 +7595,7 @@
                                       <p:cBhvr>
                                         <p:cTn id="13" dur="500"/>
                                         <p:tgtEl>
-                                          <p:spTgt spid="18"/>
+                                          <p:spTgt spid="16"/>
                                         </p:tgtEl>
                                       </p:cBhvr>
                                     </p:animEffect>
@@ -7813,7 +7616,7 @@
                                           </p:stCondLst>
                                         </p:cTn>
                                         <p:tgtEl>
-                                          <p:spTgt spid="19"/>
+                                          <p:spTgt spid="17"/>
                                         </p:tgtEl>
                                         <p:attrNameLst>
                                           <p:attrName>style.visibility</p:attrName>
@@ -7827,7 +7630,7 @@
                                       <p:cBhvr>
                                         <p:cTn id="16" dur="500"/>
                                         <p:tgtEl>
-                                          <p:spTgt spid="19"/>
+                                          <p:spTgt spid="17"/>
                                         </p:tgtEl>
                                       </p:cBhvr>
                                     </p:animEffect>
@@ -7848,7 +7651,7 @@
                                           </p:stCondLst>
                                         </p:cTn>
                                         <p:tgtEl>
-                                          <p:spTgt spid="20"/>
+                                          <p:spTgt spid="18"/>
                                         </p:tgtEl>
                                         <p:attrNameLst>
                                           <p:attrName>style.visibility</p:attrName>
@@ -7862,7 +7665,7 @@
                                       <p:cBhvr>
                                         <p:cTn id="19" dur="500"/>
                                         <p:tgtEl>
-                                          <p:spTgt spid="20"/>
+                                          <p:spTgt spid="18"/>
                                         </p:tgtEl>
                                       </p:cBhvr>
                                     </p:animEffect>
@@ -7883,7 +7686,7 @@
                                           </p:stCondLst>
                                         </p:cTn>
                                         <p:tgtEl>
-                                          <p:spTgt spid="21"/>
+                                          <p:spTgt spid="19"/>
                                         </p:tgtEl>
                                         <p:attrNameLst>
                                           <p:attrName>style.visibility</p:attrName>
@@ -7897,7 +7700,7 @@
                                       <p:cBhvr>
                                         <p:cTn id="22" dur="500"/>
                                         <p:tgtEl>
-                                          <p:spTgt spid="21"/>
+                                          <p:spTgt spid="19"/>
                                         </p:tgtEl>
                                       </p:cBhvr>
                                     </p:animEffect>
@@ -7936,7 +7739,7 @@
                                           </p:stCondLst>
                                         </p:cTn>
                                         <p:tgtEl>
-                                          <p:spTgt spid="22"/>
+                                          <p:spTgt spid="20"/>
                                         </p:tgtEl>
                                         <p:attrNameLst>
                                           <p:attrName>style.visibility</p:attrName>
@@ -7950,7 +7753,7 @@
                                       <p:cBhvr>
                                         <p:cTn id="27" dur="500"/>
                                         <p:tgtEl>
-                                          <p:spTgt spid="22"/>
+                                          <p:spTgt spid="20"/>
                                         </p:tgtEl>
                                       </p:cBhvr>
                                     </p:animEffect>
@@ -7971,7 +7774,7 @@
                                           </p:stCondLst>
                                         </p:cTn>
                                         <p:tgtEl>
-                                          <p:spTgt spid="23"/>
+                                          <p:spTgt spid="21"/>
                                         </p:tgtEl>
                                         <p:attrNameLst>
                                           <p:attrName>style.visibility</p:attrName>
@@ -7985,7 +7788,7 @@
                                       <p:cBhvr>
                                         <p:cTn id="30" dur="500"/>
                                         <p:tgtEl>
-                                          <p:spTgt spid="23"/>
+                                          <p:spTgt spid="21"/>
                                         </p:tgtEl>
                                       </p:cBhvr>
                                     </p:animEffect>
@@ -8006,7 +7809,7 @@
                                           </p:stCondLst>
                                         </p:cTn>
                                         <p:tgtEl>
-                                          <p:spTgt spid="24"/>
+                                          <p:spTgt spid="22"/>
                                         </p:tgtEl>
                                         <p:attrNameLst>
                                           <p:attrName>style.visibility</p:attrName>
@@ -8020,7 +7823,7 @@
                                       <p:cBhvr>
                                         <p:cTn id="33" dur="500"/>
                                         <p:tgtEl>
-                                          <p:spTgt spid="24"/>
+                                          <p:spTgt spid="22"/>
                                         </p:tgtEl>
                                       </p:cBhvr>
                                     </p:animEffect>
@@ -8041,7 +7844,7 @@
                                           </p:stCondLst>
                                         </p:cTn>
                                         <p:tgtEl>
-                                          <p:spTgt spid="25"/>
+                                          <p:spTgt spid="23"/>
                                         </p:tgtEl>
                                         <p:attrNameLst>
                                           <p:attrName>style.visibility</p:attrName>
@@ -8055,42 +7858,7 @@
                                       <p:cBhvr>
                                         <p:cTn id="36" dur="500"/>
                                         <p:tgtEl>
-                                          <p:spTgt spid="25"/>
-                                        </p:tgtEl>
-                                      </p:cBhvr>
-                                    </p:animEffect>
-                                  </p:childTnLst>
-                                </p:cTn>
-                              </p:par>
-                              <p:par>
-                                <p:cTn id="37" presetID="10" presetClass="entr" presetSubtype="0" fill="hold" grpId="0" nodeType="withEffect">
-                                  <p:stCondLst>
-                                    <p:cond delay="0"/>
-                                  </p:stCondLst>
-                                  <p:childTnLst>
-                                    <p:set>
-                                      <p:cBhvr>
-                                        <p:cTn id="38" dur="1" fill="hold">
-                                          <p:stCondLst>
-                                            <p:cond delay="0"/>
-                                          </p:stCondLst>
-                                        </p:cTn>
-                                        <p:tgtEl>
-                                          <p:spTgt spid="26"/>
-                                        </p:tgtEl>
-                                        <p:attrNameLst>
-                                          <p:attrName>style.visibility</p:attrName>
-                                        </p:attrNameLst>
-                                      </p:cBhvr>
-                                      <p:to>
-                                        <p:strVal val="visible"/>
-                                      </p:to>
-                                    </p:set>
-                                    <p:animEffect transition="in" filter="fade">
-                                      <p:cBhvr>
-                                        <p:cTn id="39" dur="500"/>
-                                        <p:tgtEl>
-                                          <p:spTgt spid="26"/>
+                                          <p:spTgt spid="23"/>
                                         </p:tgtEl>
                                       </p:cBhvr>
                                     </p:animEffect>
@@ -8104,19 +7872,54 @@
                     </p:cTn>
                   </p:par>
                   <p:par>
-                    <p:cTn id="40" fill="hold">
+                    <p:cTn id="37" fill="hold">
                       <p:stCondLst>
                         <p:cond delay="indefinite"/>
                       </p:stCondLst>
                       <p:childTnLst>
                         <p:par>
-                          <p:cTn id="41" fill="hold">
+                          <p:cTn id="38" fill="hold">
                             <p:stCondLst>
                               <p:cond delay="0"/>
                             </p:stCondLst>
                             <p:childTnLst>
                               <p:par>
-                                <p:cTn id="42" presetID="10" presetClass="entr" presetSubtype="0" fill="hold" nodeType="clickEffect">
+                                <p:cTn id="39" presetID="10" presetClass="entr" presetSubtype="0" fill="hold" nodeType="clickEffect">
+                                  <p:stCondLst>
+                                    <p:cond delay="0"/>
+                                  </p:stCondLst>
+                                  <p:childTnLst>
+                                    <p:set>
+                                      <p:cBhvr>
+                                        <p:cTn id="40" dur="1" fill="hold">
+                                          <p:stCondLst>
+                                            <p:cond delay="0"/>
+                                          </p:stCondLst>
+                                        </p:cTn>
+                                        <p:tgtEl>
+                                          <p:spTgt spid="24"/>
+                                        </p:tgtEl>
+                                        <p:attrNameLst>
+                                          <p:attrName>style.visibility</p:attrName>
+                                        </p:attrNameLst>
+                                      </p:cBhvr>
+                                      <p:to>
+                                        <p:strVal val="visible"/>
+                                      </p:to>
+                                    </p:set>
+                                    <p:animEffect transition="in" filter="fade">
+                                      <p:cBhvr>
+                                        <p:cTn id="41" dur="500"/>
+                                        <p:tgtEl>
+                                          <p:spTgt spid="24"/>
+                                        </p:tgtEl>
+                                      </p:cBhvr>
+                                    </p:animEffect>
+                                  </p:childTnLst>
+                                </p:cTn>
+                              </p:par>
+                              <p:par>
+                                <p:cTn id="42" presetID="10" presetClass="entr" presetSubtype="0" fill="hold" grpId="0" nodeType="withEffect">
                                   <p:stCondLst>
                                     <p:cond delay="0"/>
                                   </p:stCondLst>
@@ -8129,7 +7932,7 @@
                                           </p:stCondLst>
                                         </p:cTn>
                                         <p:tgtEl>
-                                          <p:spTgt spid="27"/>
+                                          <p:spTgt spid="25"/>
                                         </p:tgtEl>
                                         <p:attrNameLst>
                                           <p:attrName>style.visibility</p:attrName>
@@ -8143,7 +7946,7 @@
                                       <p:cBhvr>
                                         <p:cTn id="44" dur="500"/>
                                         <p:tgtEl>
-                                          <p:spTgt spid="27"/>
+                                          <p:spTgt spid="25"/>
                                         </p:tgtEl>
                                       </p:cBhvr>
                                     </p:animEffect>
@@ -8164,7 +7967,7 @@
                                           </p:stCondLst>
                                         </p:cTn>
                                         <p:tgtEl>
-                                          <p:spTgt spid="28"/>
+                                          <p:spTgt spid="26"/>
                                         </p:tgtEl>
                                         <p:attrNameLst>
                                           <p:attrName>style.visibility</p:attrName>
@@ -8178,7 +7981,7 @@
                                       <p:cBhvr>
                                         <p:cTn id="47" dur="500"/>
                                         <p:tgtEl>
-                                          <p:spTgt spid="28"/>
+                                          <p:spTgt spid="26"/>
                                         </p:tgtEl>
                                       </p:cBhvr>
                                     </p:animEffect>
@@ -8186,7 +7989,7 @@
                                 </p:cTn>
                               </p:par>
                               <p:par>
-                                <p:cTn id="48" presetID="10" presetClass="entr" presetSubtype="0" fill="hold" grpId="0" nodeType="withEffect">
+                                <p:cTn id="48" presetID="10" presetClass="entr" presetSubtype="0" fill="hold" nodeType="withEffect">
                                   <p:stCondLst>
                                     <p:cond delay="0"/>
                                   </p:stCondLst>
@@ -8199,7 +8002,7 @@
                                           </p:stCondLst>
                                         </p:cTn>
                                         <p:tgtEl>
-                                          <p:spTgt spid="29"/>
+                                          <p:spTgt spid="27"/>
                                         </p:tgtEl>
                                         <p:attrNameLst>
                                           <p:attrName>style.visibility</p:attrName>
@@ -8213,7 +8016,7 @@
                                       <p:cBhvr>
                                         <p:cTn id="50" dur="500"/>
                                         <p:tgtEl>
-                                          <p:spTgt spid="29"/>
+                                          <p:spTgt spid="27"/>
                                         </p:tgtEl>
                                       </p:cBhvr>
                                     </p:animEffect>
@@ -8221,7 +8024,7 @@
                                 </p:cTn>
                               </p:par>
                               <p:par>
-                                <p:cTn id="51" presetID="10" presetClass="entr" presetSubtype="0" fill="hold" nodeType="withEffect">
+                                <p:cTn id="51" presetID="10" presetClass="entr" presetSubtype="0" fill="hold" grpId="0" nodeType="withEffect">
                                   <p:stCondLst>
                                     <p:cond delay="0"/>
                                   </p:stCondLst>
@@ -8234,7 +8037,7 @@
                                           </p:stCondLst>
                                         </p:cTn>
                                         <p:tgtEl>
-                                          <p:spTgt spid="30"/>
+                                          <p:spTgt spid="28"/>
                                         </p:tgtEl>
                                         <p:attrNameLst>
                                           <p:attrName>style.visibility</p:attrName>
@@ -8248,77 +8051,7 @@
                                       <p:cBhvr>
                                         <p:cTn id="53" dur="500"/>
                                         <p:tgtEl>
-                                          <p:spTgt spid="30"/>
-                                        </p:tgtEl>
-                                      </p:cBhvr>
-                                    </p:animEffect>
-                                  </p:childTnLst>
-                                </p:cTn>
-                              </p:par>
-                              <p:par>
-                                <p:cTn id="54" presetID="10" presetClass="entr" presetSubtype="0" fill="hold" grpId="0" nodeType="withEffect">
-                                  <p:stCondLst>
-                                    <p:cond delay="0"/>
-                                  </p:stCondLst>
-                                  <p:childTnLst>
-                                    <p:set>
-                                      <p:cBhvr>
-                                        <p:cTn id="55" dur="1" fill="hold">
-                                          <p:stCondLst>
-                                            <p:cond delay="0"/>
-                                          </p:stCondLst>
-                                        </p:cTn>
-                                        <p:tgtEl>
-                                          <p:spTgt spid="31"/>
-                                        </p:tgtEl>
-                                        <p:attrNameLst>
-                                          <p:attrName>style.visibility</p:attrName>
-                                        </p:attrNameLst>
-                                      </p:cBhvr>
-                                      <p:to>
-                                        <p:strVal val="visible"/>
-                                      </p:to>
-                                    </p:set>
-                                    <p:animEffect transition="in" filter="fade">
-                                      <p:cBhvr>
-                                        <p:cTn id="56" dur="500"/>
-                                        <p:tgtEl>
-                                          <p:spTgt spid="31"/>
-                                        </p:tgtEl>
-                                      </p:cBhvr>
-                                    </p:animEffect>
-                                  </p:childTnLst>
-                                </p:cTn>
-                              </p:par>
-                              <p:par>
-                                <p:cTn id="57" presetID="10" presetClass="entr" presetSubtype="0" fill="hold" grpId="0" nodeType="withEffect">
-                                  <p:stCondLst>
-                                    <p:cond delay="0"/>
-                                  </p:stCondLst>
-                                  <p:childTnLst>
-                                    <p:set>
-                                      <p:cBhvr>
-                                        <p:cTn id="58" dur="1" fill="hold">
-                                          <p:stCondLst>
-                                            <p:cond delay="0"/>
-                                          </p:stCondLst>
-                                        </p:cTn>
-                                        <p:tgtEl>
-                                          <p:spTgt spid="32"/>
-                                        </p:tgtEl>
-                                        <p:attrNameLst>
-                                          <p:attrName>style.visibility</p:attrName>
-                                        </p:attrNameLst>
-                                      </p:cBhvr>
-                                      <p:to>
-                                        <p:strVal val="visible"/>
-                                      </p:to>
-                                    </p:set>
-                                    <p:animEffect transition="in" filter="fade">
-                                      <p:cBhvr>
-                                        <p:cTn id="59" dur="500"/>
-                                        <p:tgtEl>
-                                          <p:spTgt spid="32"/>
+                                          <p:spTgt spid="28"/>
                                         </p:tgtEl>
                                       </p:cBhvr>
                                     </p:animEffect>
@@ -8353,17 +8086,15 @@
       </p:par>
     </p:tnLst>
     <p:bldLst>
-      <p:bldP spid="17" grpId="0" animBg="1"/>
-      <p:bldP spid="18" grpId="0" animBg="1"/>
+      <p:bldP spid="15" grpId="0" animBg="1"/>
+      <p:bldP spid="16" grpId="0" animBg="1"/>
+      <p:bldP spid="19" grpId="0" animBg="1"/>
       <p:bldP spid="21" grpId="0" animBg="1"/>
+      <p:bldP spid="22" grpId="0" animBg="1"/>
       <p:bldP spid="23" grpId="0" animBg="1"/>
-      <p:bldP spid="24" grpId="0" animBg="1"/>
       <p:bldP spid="25" grpId="0" animBg="1"/>
       <p:bldP spid="26" grpId="0" animBg="1"/>
       <p:bldP spid="28" grpId="0" animBg="1"/>
-      <p:bldP spid="29" grpId="0" animBg="1"/>
-      <p:bldP spid="31" grpId="0" animBg="1"/>
-      <p:bldP spid="32" grpId="0" animBg="1"/>
     </p:bldLst>
   </p:timing>
 </p:sld>
@@ -8513,11 +8244,11 @@
         <p:spPr>
           <a:xfrm>
             <a:off x="548640" y="1554480"/>
-            <a:ext cx="4846320" cy="3236976"/>
+            <a:ext cx="4846320" cy="3328416"/>
           </a:xfrm>
           <a:prstGeom prst="roundRect">
             <a:avLst>
-              <a:gd name="adj" fmla="val 2260"/>
+              <a:gd name="adj" fmla="val 2198"/>
             </a:avLst>
           </a:prstGeom>
           <a:solidFill>
@@ -8540,7 +8271,7 @@
         <p:spPr>
           <a:xfrm>
             <a:off x="658368" y="1755648"/>
-            <a:ext cx="274320" cy="566928"/>
+            <a:ext cx="274320" cy="731520"/>
           </a:xfrm>
           <a:prstGeom prst="rect">
             <a:avLst/>
@@ -8579,7 +8310,7 @@
         <p:spPr>
           <a:xfrm>
             <a:off x="1188720" y="1755648"/>
-            <a:ext cx="4114800" cy="566928"/>
+            <a:ext cx="4114800" cy="731520"/>
           </a:xfrm>
           <a:prstGeom prst="rect">
             <a:avLst/>
@@ -8715,8 +8446,8 @@
         </p:nvSpPr>
         <p:spPr>
           <a:xfrm>
-            <a:off x="658368" y="2322576"/>
-            <a:ext cx="274320" cy="566928"/>
+            <a:off x="658368" y="2487168"/>
+            <a:ext cx="274320" cy="731520"/>
           </a:xfrm>
           <a:prstGeom prst="rect">
             <a:avLst/>
@@ -8754,8 +8485,8 @@
         </p:nvSpPr>
         <p:spPr>
           <a:xfrm>
-            <a:off x="1188720" y="2322576"/>
-            <a:ext cx="4114800" cy="566928"/>
+            <a:off x="1188720" y="2487168"/>
+            <a:ext cx="4114800" cy="731520"/>
           </a:xfrm>
           <a:prstGeom prst="rect">
             <a:avLst/>
@@ -8849,8 +8580,8 @@
         </p:nvSpPr>
         <p:spPr>
           <a:xfrm>
-            <a:off x="658368" y="2889504"/>
-            <a:ext cx="274320" cy="566928"/>
+            <a:off x="658368" y="3218688"/>
+            <a:ext cx="274320" cy="731520"/>
           </a:xfrm>
           <a:prstGeom prst="rect">
             <a:avLst/>
@@ -8888,8 +8619,8 @@
         </p:nvSpPr>
         <p:spPr>
           <a:xfrm>
-            <a:off x="1188720" y="2889504"/>
-            <a:ext cx="4114800" cy="566928"/>
+            <a:off x="1188720" y="3218688"/>
+            <a:ext cx="4114800" cy="731520"/>
           </a:xfrm>
           <a:prstGeom prst="rect">
             <a:avLst/>
@@ -8941,8 +8672,8 @@
         </p:nvSpPr>
         <p:spPr>
           <a:xfrm>
-            <a:off x="658368" y="3456432"/>
-            <a:ext cx="274320" cy="566928"/>
+            <a:off x="658368" y="3950208"/>
+            <a:ext cx="274320" cy="731520"/>
           </a:xfrm>
           <a:prstGeom prst="rect">
             <a:avLst/>
@@ -8980,8 +8711,8 @@
         </p:nvSpPr>
         <p:spPr>
           <a:xfrm>
-            <a:off x="1188720" y="3456432"/>
-            <a:ext cx="4114800" cy="566928"/>
+            <a:off x="1188720" y="3950208"/>
+            <a:ext cx="4114800" cy="731520"/>
           </a:xfrm>
           <a:prstGeom prst="rect">
             <a:avLst/>
@@ -9069,133 +8800,13 @@
       </p:sp>
       <p:sp>
         <p:nvSpPr>
-          <p:cNvPr id="14" name="Text 11"/>
-          <p:cNvSpPr txBox="1"/>
-          <p:nvPr/>
-        </p:nvSpPr>
-        <p:spPr>
-          <a:xfrm>
-            <a:off x="658368" y="4023360"/>
-            <a:ext cx="274320" cy="566928"/>
-          </a:xfrm>
-          <a:prstGeom prst="rect">
-            <a:avLst/>
-          </a:prstGeom>
-          <a:noFill/>
-          <a:ln/>
-        </p:spPr>
-        <p:txBody>
-          <a:bodyPr wrap="square" lIns="0" tIns="0" rIns="0" bIns="0" rtlCol="0" anchor="ctr"/>
-          <a:lstStyle/>
-          <a:p>
-            <a:pPr algn="r" indent="0" marL="0">
-              <a:buNone/>
-            </a:pPr>
-            <a:r>
-              <a:rPr lang="en-US" sz="2000" dirty="0">
-                <a:solidFill>
-                  <a:srgbClr val="6E6E7A"/>
-                </a:solidFill>
-                <a:latin typeface="Consolas" pitchFamily="34" charset="0"/>
-                <a:ea typeface="Consolas" pitchFamily="34" charset="-122"/>
-                <a:cs typeface="Consolas" pitchFamily="34" charset="-120"/>
-              </a:rPr>
-              <a:t>5</a:t>
-            </a:r>
-            <a:endParaRPr lang="en-US" sz="2000" dirty="0"/>
-          </a:p>
-        </p:txBody>
-      </p:sp>
-      <p:sp>
-        <p:nvSpPr>
-          <p:cNvPr id="15" name="Text 12"/>
-          <p:cNvSpPr txBox="1"/>
-          <p:nvPr/>
-        </p:nvSpPr>
-        <p:spPr>
-          <a:xfrm>
-            <a:off x="1188720" y="4023360"/>
-            <a:ext cx="4114800" cy="566928"/>
-          </a:xfrm>
-          <a:prstGeom prst="rect">
-            <a:avLst/>
-          </a:prstGeom>
-          <a:noFill/>
-          <a:ln/>
-        </p:spPr>
-        <p:txBody>
-          <a:bodyPr wrap="square" lIns="0" tIns="0" rIns="0" bIns="0" rtlCol="0" anchor="ctr"/>
-          <a:lstStyle/>
-          <a:p>
-            <a:pPr indent="0" marL="0">
-              <a:buNone/>
-            </a:pPr>
-            <a:r>
-              <a:rPr lang="en-US" sz="2400" dirty="0">
-                <a:solidFill>
-                  <a:srgbClr val="E8C878"/>
-                </a:solidFill>
-                <a:latin typeface="Consolas" pitchFamily="34" charset="0"/>
-                <a:ea typeface="Consolas" pitchFamily="34" charset="-122"/>
-                <a:cs typeface="Consolas" pitchFamily="34" charset="-120"/>
-              </a:rPr>
-              <a:t>print</a:t>
-            </a:r>
-            <a:pPr indent="0" marL="0">
-              <a:buNone/>
-            </a:pPr>
-            <a:r>
-              <a:rPr lang="en-US" sz="2400" dirty="0">
-                <a:solidFill>
-                  <a:srgbClr val="A9A9B4"/>
-                </a:solidFill>
-                <a:latin typeface="Consolas" pitchFamily="34" charset="0"/>
-                <a:ea typeface="Consolas" pitchFamily="34" charset="-122"/>
-                <a:cs typeface="Consolas" pitchFamily="34" charset="-120"/>
-              </a:rPr>
-              <a:t>(</a:t>
-            </a:r>
-            <a:pPr indent="0" marL="0">
-              <a:buNone/>
-            </a:pPr>
-            <a:r>
-              <a:rPr lang="en-US" sz="2400" dirty="0">
-                <a:solidFill>
-                  <a:srgbClr val="E69F00"/>
-                </a:solidFill>
-                <a:latin typeface="Consolas" pitchFamily="34" charset="0"/>
-                <a:ea typeface="Consolas" pitchFamily="34" charset="-122"/>
-                <a:cs typeface="Consolas" pitchFamily="34" charset="-120"/>
-              </a:rPr>
-              <a:t>"Done"</a:t>
-            </a:r>
-            <a:pPr indent="0" marL="0">
-              <a:buNone/>
-            </a:pPr>
-            <a:r>
-              <a:rPr lang="en-US" sz="2400" dirty="0">
-                <a:solidFill>
-                  <a:srgbClr val="A9A9B4"/>
-                </a:solidFill>
-                <a:latin typeface="Consolas" pitchFamily="34" charset="0"/>
-                <a:ea typeface="Consolas" pitchFamily="34" charset="-122"/>
-                <a:cs typeface="Consolas" pitchFamily="34" charset="-120"/>
-              </a:rPr>
-              <a:t>)</a:t>
-            </a:r>
-            <a:endParaRPr lang="en-US" sz="2400" dirty="0"/>
-          </a:p>
-        </p:txBody>
-      </p:sp>
-      <p:sp>
-        <p:nvSpPr>
-          <p:cNvPr id="16" name="click1"/>
+          <p:cNvPr id="14" name="click1"/>
           <p:cNvSpPr/>
           <p:nvPr/>
         </p:nvSpPr>
         <p:spPr>
           <a:xfrm>
-            <a:off x="5623560" y="1874520"/>
+            <a:off x="5623560" y="1956816"/>
             <a:ext cx="329184" cy="329184"/>
           </a:xfrm>
           <a:prstGeom prst="ellipse">
@@ -9209,13 +8820,13 @@
       </p:sp>
       <p:sp>
         <p:nvSpPr>
-          <p:cNvPr id="17" name="click1"/>
-          <p:cNvSpPr txBox="1"/>
-          <p:nvPr/>
-        </p:nvSpPr>
-        <p:spPr>
-          <a:xfrm>
-            <a:off x="5623560" y="1874520"/>
+          <p:cNvPr id="15" name="click1"/>
+          <p:cNvSpPr txBox="1"/>
+          <p:nvPr/>
+        </p:nvSpPr>
+        <p:spPr>
+          <a:xfrm>
+            <a:off x="5623560" y="1956816"/>
             <a:ext cx="329184" cy="329184"/>
           </a:xfrm>
           <a:prstGeom prst="rect">
@@ -9248,14 +8859,14 @@
       </p:sp>
       <p:sp>
         <p:nvSpPr>
-          <p:cNvPr id="18" name="click1"/>
+          <p:cNvPr id="16" name="click1"/>
           <p:cNvSpPr txBox="1"/>
           <p:nvPr/>
         </p:nvSpPr>
         <p:spPr>
           <a:xfrm>
             <a:off x="6053328" y="1755648"/>
-            <a:ext cx="1417320" cy="566928"/>
+            <a:ext cx="1417320" cy="731520"/>
           </a:xfrm>
           <a:prstGeom prst="rect">
             <a:avLst/>
@@ -9343,13 +8954,13 @@
       </p:sp>
       <p:sp>
         <p:nvSpPr>
-          <p:cNvPr id="19" name="click1"/>
+          <p:cNvPr id="17" name="click1"/>
           <p:cNvSpPr/>
           <p:nvPr/>
         </p:nvSpPr>
         <p:spPr>
           <a:xfrm>
-            <a:off x="7516368" y="2039112"/>
+            <a:off x="7516368" y="2121408"/>
             <a:ext cx="365760" cy="0"/>
           </a:xfrm>
           <a:prstGeom prst="line">
@@ -9367,18 +8978,18 @@
       </p:sp>
       <p:sp>
         <p:nvSpPr>
-          <p:cNvPr id="20" name="click1"/>
+          <p:cNvPr id="18" name="click1"/>
           <p:cNvSpPr/>
           <p:nvPr/>
         </p:nvSpPr>
         <p:spPr>
           <a:xfrm>
             <a:off x="7973568" y="1819656"/>
-            <a:ext cx="868680" cy="438912"/>
+            <a:ext cx="868680" cy="603504"/>
           </a:xfrm>
           <a:prstGeom prst="roundRect">
             <a:avLst>
-              <a:gd name="adj" fmla="val 16667"/>
+              <a:gd name="adj" fmla="val 12121"/>
             </a:avLst>
           </a:prstGeom>
           <a:solidFill>
@@ -9389,14 +9000,14 @@
       </p:sp>
       <p:sp>
         <p:nvSpPr>
-          <p:cNvPr id="21" name="click1"/>
+          <p:cNvPr id="19" name="click1"/>
           <p:cNvSpPr txBox="1"/>
           <p:nvPr/>
         </p:nvSpPr>
         <p:spPr>
           <a:xfrm>
             <a:off x="7973568" y="1819656"/>
-            <a:ext cx="868680" cy="438912"/>
+            <a:ext cx="868680" cy="603504"/>
           </a:xfrm>
           <a:prstGeom prst="rect">
             <a:avLst/>
@@ -9428,13 +9039,13 @@
       </p:sp>
       <p:sp>
         <p:nvSpPr>
-          <p:cNvPr id="22" name="click2"/>
+          <p:cNvPr id="20" name="click2"/>
           <p:cNvSpPr/>
           <p:nvPr/>
         </p:nvSpPr>
         <p:spPr>
           <a:xfrm>
-            <a:off x="5623560" y="2441448"/>
+            <a:off x="5623560" y="2688336"/>
             <a:ext cx="329184" cy="329184"/>
           </a:xfrm>
           <a:prstGeom prst="ellipse">
@@ -9448,13 +9059,13 @@
       </p:sp>
       <p:sp>
         <p:nvSpPr>
-          <p:cNvPr id="23" name="click2"/>
-          <p:cNvSpPr txBox="1"/>
-          <p:nvPr/>
-        </p:nvSpPr>
-        <p:spPr>
-          <a:xfrm>
-            <a:off x="5623560" y="2441448"/>
+          <p:cNvPr id="21" name="click2"/>
+          <p:cNvSpPr txBox="1"/>
+          <p:nvPr/>
+        </p:nvSpPr>
+        <p:spPr>
+          <a:xfrm>
+            <a:off x="5623560" y="2688336"/>
             <a:ext cx="329184" cy="329184"/>
           </a:xfrm>
           <a:prstGeom prst="rect">
@@ -9487,14 +9098,14 @@
       </p:sp>
       <p:sp>
         <p:nvSpPr>
-          <p:cNvPr id="24" name="click2"/>
-          <p:cNvSpPr txBox="1"/>
-          <p:nvPr/>
-        </p:nvSpPr>
-        <p:spPr>
-          <a:xfrm>
-            <a:off x="6053328" y="2322576"/>
-            <a:ext cx="2651760" cy="566928"/>
+          <p:cNvPr id="22" name="click2"/>
+          <p:cNvSpPr txBox="1"/>
+          <p:nvPr/>
+        </p:nvSpPr>
+        <p:spPr>
+          <a:xfrm>
+            <a:off x="6053328" y="2487168"/>
+            <a:ext cx="2651760" cy="731520"/>
           </a:xfrm>
           <a:prstGeom prst="rect">
             <a:avLst/>
@@ -9526,14 +9137,14 @@
       </p:sp>
       <p:sp>
         <p:nvSpPr>
-          <p:cNvPr id="25" name="click2"/>
-          <p:cNvSpPr txBox="1"/>
-          <p:nvPr/>
-        </p:nvSpPr>
-        <p:spPr>
-          <a:xfrm>
-            <a:off x="6053328" y="3456432"/>
-            <a:ext cx="2651760" cy="566928"/>
+          <p:cNvPr id="23" name="click2"/>
+          <p:cNvSpPr txBox="1"/>
+          <p:nvPr/>
+        </p:nvSpPr>
+        <p:spPr>
+          <a:xfrm>
+            <a:off x="6053328" y="3950208"/>
+            <a:ext cx="2651760" cy="731520"/>
           </a:xfrm>
           <a:prstGeom prst="rect">
             <a:avLst/>
@@ -9565,155 +9176,116 @@
       </p:sp>
       <p:sp>
         <p:nvSpPr>
-          <p:cNvPr id="26" name="click2"/>
-          <p:cNvSpPr txBox="1"/>
-          <p:nvPr/>
-        </p:nvSpPr>
-        <p:spPr>
-          <a:xfrm>
-            <a:off x="6053328" y="4023360"/>
-            <a:ext cx="2651760" cy="566928"/>
-          </a:xfrm>
-          <a:prstGeom prst="rect">
-            <a:avLst/>
-          </a:prstGeom>
-          <a:noFill/>
-          <a:ln/>
-        </p:spPr>
-        <p:txBody>
-          <a:bodyPr wrap="square" lIns="0" tIns="0" rIns="0" bIns="0" rtlCol="0" anchor="ctr"/>
-          <a:lstStyle/>
-          <a:p>
-            <a:pPr indent="0" marL="0">
-              <a:buNone/>
-            </a:pPr>
-            <a:r>
-              <a:rPr lang="en-US" sz="2000" b="1" dirty="0">
-                <a:solidFill>
-                  <a:srgbClr val="D8A73D"/>
+          <p:cNvPr id="24" name="click3"/>
+          <p:cNvSpPr/>
+          <p:nvPr/>
+        </p:nvSpPr>
+        <p:spPr>
+          <a:xfrm>
+            <a:off x="9098280" y="1554480"/>
+            <a:ext cx="329184" cy="329184"/>
+          </a:xfrm>
+          <a:prstGeom prst="ellipse">
+            <a:avLst/>
+          </a:prstGeom>
+          <a:solidFill>
+            <a:srgbClr val="D8A73D"/>
+          </a:solidFill>
+          <a:ln/>
+        </p:spPr>
+      </p:sp>
+      <p:sp>
+        <p:nvSpPr>
+          <p:cNvPr id="25" name="click3"/>
+          <p:cNvSpPr txBox="1"/>
+          <p:nvPr/>
+        </p:nvSpPr>
+        <p:spPr>
+          <a:xfrm>
+            <a:off x="9098280" y="1554480"/>
+            <a:ext cx="329184" cy="329184"/>
+          </a:xfrm>
+          <a:prstGeom prst="rect">
+            <a:avLst/>
+          </a:prstGeom>
+          <a:noFill/>
+          <a:ln/>
+        </p:spPr>
+        <p:txBody>
+          <a:bodyPr wrap="square" lIns="0" tIns="0" rIns="0" bIns="0" rtlCol="0" anchor="ctr"/>
+          <a:lstStyle/>
+          <a:p>
+            <a:pPr algn="ctr" indent="0" marL="0">
+              <a:buNone/>
+            </a:pPr>
+            <a:r>
+              <a:rPr lang="en-US" sz="1600" b="1" dirty="0">
+                <a:solidFill>
+                  <a:srgbClr val="1E1E24"/>
+                </a:solidFill>
+                <a:latin typeface="Cambria" pitchFamily="34" charset="0"/>
+                <a:ea typeface="Cambria" pitchFamily="34" charset="-122"/>
+                <a:cs typeface="Cambria" pitchFamily="34" charset="-120"/>
+              </a:rPr>
+              <a:t>3</a:t>
+            </a:r>
+            <a:endParaRPr lang="en-US" sz="1600" dirty="0"/>
+          </a:p>
+        </p:txBody>
+      </p:sp>
+      <p:sp>
+        <p:nvSpPr>
+          <p:cNvPr id="26" name="click3"/>
+          <p:cNvSpPr txBox="1"/>
+          <p:nvPr/>
+        </p:nvSpPr>
+        <p:spPr>
+          <a:xfrm>
+            <a:off x="9555480" y="1554480"/>
+            <a:ext cx="2084832" cy="329184"/>
+          </a:xfrm>
+          <a:prstGeom prst="rect">
+            <a:avLst/>
+          </a:prstGeom>
+          <a:noFill/>
+          <a:ln/>
+        </p:spPr>
+        <p:txBody>
+          <a:bodyPr wrap="square" lIns="0" tIns="0" rIns="0" bIns="0" rtlCol="0" anchor="ctr"/>
+          <a:lstStyle/>
+          <a:p>
+            <a:pPr indent="0" marL="0">
+              <a:buNone/>
+            </a:pPr>
+            <a:r>
+              <a:rPr lang="en-US" sz="1300" b="1" spc="200" kern="0" dirty="0">
+                <a:solidFill>
+                  <a:srgbClr val="6E6E7A"/>
                 </a:solidFill>
                 <a:latin typeface="Calibri" pitchFamily="34" charset="0"/>
                 <a:ea typeface="Calibri" pitchFamily="34" charset="-122"/>
                 <a:cs typeface="Calibri" pitchFamily="34" charset="-120"/>
               </a:rPr>
-              <a:t>✓ runs every time</a:t>
-            </a:r>
-            <a:endParaRPr lang="en-US" sz="2000" dirty="0"/>
-          </a:p>
-        </p:txBody>
-      </p:sp>
-      <p:sp>
-        <p:nvSpPr>
-          <p:cNvPr id="27" name="click3"/>
+              <a:t>WHAT IS PRINTED</a:t>
+            </a:r>
+            <a:endParaRPr lang="en-US" sz="1300" dirty="0"/>
+          </a:p>
+        </p:txBody>
+      </p:sp>
+      <p:sp>
+        <p:nvSpPr>
+          <p:cNvPr id="27" name="click3 · terminal"/>
           <p:cNvSpPr/>
           <p:nvPr/>
         </p:nvSpPr>
         <p:spPr>
           <a:xfrm>
-            <a:off x="9098280" y="1554480"/>
-            <a:ext cx="329184" cy="329184"/>
-          </a:xfrm>
-          <a:prstGeom prst="ellipse">
-            <a:avLst/>
-          </a:prstGeom>
-          <a:solidFill>
-            <a:srgbClr val="D8A73D"/>
-          </a:solidFill>
-          <a:ln/>
-        </p:spPr>
-      </p:sp>
-      <p:sp>
-        <p:nvSpPr>
-          <p:cNvPr id="28" name="click3"/>
-          <p:cNvSpPr txBox="1"/>
-          <p:nvPr/>
-        </p:nvSpPr>
-        <p:spPr>
-          <a:xfrm>
-            <a:off x="9098280" y="1554480"/>
-            <a:ext cx="329184" cy="329184"/>
-          </a:xfrm>
-          <a:prstGeom prst="rect">
-            <a:avLst/>
-          </a:prstGeom>
-          <a:noFill/>
-          <a:ln/>
-        </p:spPr>
-        <p:txBody>
-          <a:bodyPr wrap="square" lIns="0" tIns="0" rIns="0" bIns="0" rtlCol="0" anchor="ctr"/>
-          <a:lstStyle/>
-          <a:p>
-            <a:pPr algn="ctr" indent="0" marL="0">
-              <a:buNone/>
-            </a:pPr>
-            <a:r>
-              <a:rPr lang="en-US" sz="1600" b="1" dirty="0">
-                <a:solidFill>
-                  <a:srgbClr val="1E1E24"/>
-                </a:solidFill>
-                <a:latin typeface="Cambria" pitchFamily="34" charset="0"/>
-                <a:ea typeface="Cambria" pitchFamily="34" charset="-122"/>
-                <a:cs typeface="Cambria" pitchFamily="34" charset="-120"/>
-              </a:rPr>
-              <a:t>3</a:t>
-            </a:r>
-            <a:endParaRPr lang="en-US" sz="1600" dirty="0"/>
-          </a:p>
-        </p:txBody>
-      </p:sp>
-      <p:sp>
-        <p:nvSpPr>
-          <p:cNvPr id="29" name="click3"/>
-          <p:cNvSpPr txBox="1"/>
-          <p:nvPr/>
-        </p:nvSpPr>
-        <p:spPr>
-          <a:xfrm>
-            <a:off x="9555480" y="1554480"/>
-            <a:ext cx="2084832" cy="329184"/>
-          </a:xfrm>
-          <a:prstGeom prst="rect">
-            <a:avLst/>
-          </a:prstGeom>
-          <a:noFill/>
-          <a:ln/>
-        </p:spPr>
-        <p:txBody>
-          <a:bodyPr wrap="square" lIns="0" tIns="0" rIns="0" bIns="0" rtlCol="0" anchor="ctr"/>
-          <a:lstStyle/>
-          <a:p>
-            <a:pPr indent="0" marL="0">
-              <a:buNone/>
-            </a:pPr>
-            <a:r>
-              <a:rPr lang="en-US" sz="1300" b="1" spc="200" kern="0" dirty="0">
-                <a:solidFill>
-                  <a:srgbClr val="6E6E7A"/>
-                </a:solidFill>
-                <a:latin typeface="Calibri" pitchFamily="34" charset="0"/>
-                <a:ea typeface="Calibri" pitchFamily="34" charset="-122"/>
-                <a:cs typeface="Calibri" pitchFamily="34" charset="-120"/>
-              </a:rPr>
-              <a:t>WHAT IS PRINTED</a:t>
-            </a:r>
-            <a:endParaRPr lang="en-US" sz="1300" dirty="0"/>
-          </a:p>
-        </p:txBody>
-      </p:sp>
-      <p:sp>
-        <p:nvSpPr>
-          <p:cNvPr id="30" name="click3 · terminal"/>
-          <p:cNvSpPr/>
-          <p:nvPr/>
-        </p:nvSpPr>
-        <p:spPr>
-          <a:xfrm>
             <a:off x="9098280" y="2011680"/>
-            <a:ext cx="2542032" cy="1270000"/>
+            <a:ext cx="2542032" cy="863600"/>
           </a:xfrm>
           <a:prstGeom prst="roundRect">
             <a:avLst>
-              <a:gd name="adj" fmla="val 5760"/>
+              <a:gd name="adj" fmla="val 8471"/>
             </a:avLst>
           </a:prstGeom>
           <a:solidFill>
@@ -9729,7 +9301,7 @@
       </p:sp>
       <p:sp>
         <p:nvSpPr>
-          <p:cNvPr id="31" name="click3"/>
+          <p:cNvPr id="28" name="click3"/>
           <p:cNvSpPr txBox="1"/>
           <p:nvPr/>
         </p:nvSpPr>
@@ -9768,46 +9340,7 @@
       </p:sp>
       <p:sp>
         <p:nvSpPr>
-          <p:cNvPr id="32" name="click3"/>
-          <p:cNvSpPr txBox="1"/>
-          <p:nvPr/>
-        </p:nvSpPr>
-        <p:spPr>
-          <a:xfrm>
-            <a:off x="9326880" y="2646680"/>
-            <a:ext cx="2084832" cy="406400"/>
-          </a:xfrm>
-          <a:prstGeom prst="rect">
-            <a:avLst/>
-          </a:prstGeom>
-          <a:noFill/>
-          <a:ln/>
-        </p:spPr>
-        <p:txBody>
-          <a:bodyPr wrap="square" lIns="0" tIns="0" rIns="0" bIns="0" rtlCol="0" anchor="ctr"/>
-          <a:lstStyle/>
-          <a:p>
-            <a:pPr indent="0" marL="0">
-              <a:buNone/>
-            </a:pPr>
-            <a:r>
-              <a:rPr lang="en-US" sz="2000" dirty="0">
-                <a:solidFill>
-                  <a:srgbClr val="F5F5F3"/>
-                </a:solidFill>
-                <a:latin typeface="Consolas" pitchFamily="34" charset="0"/>
-                <a:ea typeface="Consolas" pitchFamily="34" charset="-122"/>
-                <a:cs typeface="Consolas" pitchFamily="34" charset="-120"/>
-              </a:rPr>
-              <a:t>Done</a:t>
-            </a:r>
-            <a:endParaRPr lang="en-US" sz="2000" dirty="0"/>
-          </a:p>
-        </p:txBody>
-      </p:sp>
-      <p:sp>
-        <p:nvSpPr>
-          <p:cNvPr id="33" name="Shape 30"/>
+          <p:cNvPr id="29" name="Shape 26"/>
           <p:cNvSpPr/>
           <p:nvPr/>
         </p:nvSpPr>
@@ -9829,7 +9362,7 @@
       </p:sp>
       <p:sp>
         <p:nvSpPr>
-          <p:cNvPr id="34" name="Shape 31"/>
+          <p:cNvPr id="30" name="Shape 27"/>
           <p:cNvSpPr/>
           <p:nvPr/>
         </p:nvSpPr>
@@ -9849,7 +9382,7 @@
       </p:sp>
       <p:sp>
         <p:nvSpPr>
-          <p:cNvPr id="35" name="Text 32"/>
+          <p:cNvPr id="31" name="Text 28"/>
           <p:cNvSpPr txBox="1"/>
           <p:nvPr/>
         </p:nvSpPr>
@@ -9888,7 +9421,7 @@
       </p:sp>
       <p:sp>
         <p:nvSpPr>
-          <p:cNvPr id="36" name="Text 33"/>
+          <p:cNvPr id="32" name="Text 29"/>
           <p:cNvSpPr txBox="1"/>
           <p:nvPr/>
         </p:nvSpPr>
@@ -9927,7 +9460,7 @@
       </p:sp>
       <p:sp>
         <p:nvSpPr>
-          <p:cNvPr id="37" name="Shape 34"/>
+          <p:cNvPr id="33" name="Shape 30"/>
           <p:cNvSpPr/>
           <p:nvPr/>
         </p:nvSpPr>
@@ -9947,7 +9480,7 @@
       </p:sp>
       <p:sp>
         <p:nvSpPr>
-          <p:cNvPr id="38" name="Text 35"/>
+          <p:cNvPr id="34" name="Text 31"/>
           <p:cNvSpPr txBox="1"/>
           <p:nvPr/>
         </p:nvSpPr>
@@ -9986,7 +9519,7 @@
       </p:sp>
       <p:sp>
         <p:nvSpPr>
-          <p:cNvPr id="39" name="Text 36"/>
+          <p:cNvPr id="35" name="Text 32"/>
           <p:cNvSpPr txBox="1"/>
           <p:nvPr/>
         </p:nvSpPr>
@@ -10025,7 +9558,7 @@
       </p:sp>
       <p:sp>
         <p:nvSpPr>
-          <p:cNvPr id="40" name="Shape 37"/>
+          <p:cNvPr id="36" name="Shape 33"/>
           <p:cNvSpPr/>
           <p:nvPr/>
         </p:nvSpPr>
@@ -10045,7 +9578,7 @@
       </p:sp>
       <p:sp>
         <p:nvSpPr>
-          <p:cNvPr id="41" name="Text 38"/>
+          <p:cNvPr id="37" name="Text 34"/>
           <p:cNvSpPr txBox="1"/>
           <p:nvPr/>
         </p:nvSpPr>
@@ -10084,7 +9617,7 @@
       </p:sp>
       <p:sp>
         <p:nvSpPr>
-          <p:cNvPr id="42" name="Text 39"/>
+          <p:cNvPr id="38" name="Text 35"/>
           <p:cNvSpPr txBox="1"/>
           <p:nvPr/>
         </p:nvSpPr>
@@ -10123,7 +9656,7 @@
       </p:sp>
       <p:sp>
         <p:nvSpPr>
-          <p:cNvPr id="43" name="Shape 40"/>
+          <p:cNvPr id="39" name="Shape 36"/>
           <p:cNvSpPr/>
           <p:nvPr/>
         </p:nvSpPr>
@@ -10145,7 +9678,7 @@
       </p:sp>
       <p:sp>
         <p:nvSpPr>
-          <p:cNvPr id="44" name="Text 41"/>
+          <p:cNvPr id="40" name="Text 37"/>
           <p:cNvSpPr txBox="1"/>
           <p:nvPr/>
         </p:nvSpPr>
@@ -10184,7 +9717,7 @@
       </p:sp>
       <p:pic>
         <p:nvPicPr>
-          <p:cNvPr id="45" name="Image 1" descr="Deliberate practice">    </p:cNvPr>
+          <p:cNvPr id="41" name="Image 1" descr="Deliberate practice">    </p:cNvPr>
           <p:cNvPicPr>
             <a:picLocks noChangeAspect="1"/>
           </p:cNvPicPr>
@@ -10208,7 +9741,7 @@
       </p:pic>
       <p:sp>
         <p:nvSpPr>
-          <p:cNvPr id="25" name="Slide Number Placeholder 0"/>
+          <p:cNvPr id="42" name="Slide Number Placeholder 0"/>
           <p:cNvSpPr>
             <a:spLocks noGrp="1"/>
           </p:cNvSpPr>
@@ -10293,7 +9826,7 @@
                                           </p:stCondLst>
                                         </p:cTn>
                                         <p:tgtEl>
-                                          <p:spTgt spid="16"/>
+                                          <p:spTgt spid="14"/>
                                         </p:tgtEl>
                                         <p:attrNameLst>
                                           <p:attrName>style.visibility</p:attrName>
@@ -10307,7 +9840,7 @@
                                       <p:cBhvr>
                                         <p:cTn id="7" dur="500"/>
                                         <p:tgtEl>
-                                          <p:spTgt spid="16"/>
+                                          <p:spTgt spid="14"/>
                                         </p:tgtEl>
                                       </p:cBhvr>
                                     </p:animEffect>
@@ -10328,7 +9861,7 @@
                                           </p:stCondLst>
                                         </p:cTn>
                                         <p:tgtEl>
-                                          <p:spTgt spid="17"/>
+                                          <p:spTgt spid="15"/>
                                         </p:tgtEl>
                                         <p:attrNameLst>
                                           <p:attrName>style.visibility</p:attrName>
@@ -10342,7 +9875,7 @@
                                       <p:cBhvr>
                                         <p:cTn id="10" dur="500"/>
                                         <p:tgtEl>
-                                          <p:spTgt spid="17"/>
+                                          <p:spTgt spid="15"/>
                                         </p:tgtEl>
                                       </p:cBhvr>
                                     </p:animEffect>
@@ -10363,7 +9896,7 @@
                                           </p:stCondLst>
                                         </p:cTn>
                                         <p:tgtEl>
-                                          <p:spTgt spid="18"/>
+                                          <p:spTgt spid="16"/>
                                         </p:tgtEl>
                                         <p:attrNameLst>
                                           <p:attrName>style.visibility</p:attrName>
@@ -10377,7 +9910,7 @@
                                       <p:cBhvr>
                                         <p:cTn id="13" dur="500"/>
                                         <p:tgtEl>
-                                          <p:spTgt spid="18"/>
+                                          <p:spTgt spid="16"/>
                                         </p:tgtEl>
                                       </p:cBhvr>
                                     </p:animEffect>
@@ -10398,7 +9931,7 @@
                                           </p:stCondLst>
                                         </p:cTn>
                                         <p:tgtEl>
-                                          <p:spTgt spid="19"/>
+                                          <p:spTgt spid="17"/>
                                         </p:tgtEl>
                                         <p:attrNameLst>
                                           <p:attrName>style.visibility</p:attrName>
@@ -10412,7 +9945,7 @@
                                       <p:cBhvr>
                                         <p:cTn id="16" dur="500"/>
                                         <p:tgtEl>
-                                          <p:spTgt spid="19"/>
+                                          <p:spTgt spid="17"/>
                                         </p:tgtEl>
                                       </p:cBhvr>
                                     </p:animEffect>
@@ -10433,7 +9966,7 @@
                                           </p:stCondLst>
                                         </p:cTn>
                                         <p:tgtEl>
-                                          <p:spTgt spid="20"/>
+                                          <p:spTgt spid="18"/>
                                         </p:tgtEl>
                                         <p:attrNameLst>
                                           <p:attrName>style.visibility</p:attrName>
@@ -10447,7 +9980,7 @@
                                       <p:cBhvr>
                                         <p:cTn id="19" dur="500"/>
                                         <p:tgtEl>
-                                          <p:spTgt spid="20"/>
+                                          <p:spTgt spid="18"/>
                                         </p:tgtEl>
                                       </p:cBhvr>
                                     </p:animEffect>
@@ -10468,7 +10001,7 @@
                                           </p:stCondLst>
                                         </p:cTn>
                                         <p:tgtEl>
-                                          <p:spTgt spid="21"/>
+                                          <p:spTgt spid="19"/>
                                         </p:tgtEl>
                                         <p:attrNameLst>
                                           <p:attrName>style.visibility</p:attrName>
@@ -10482,7 +10015,7 @@
                                       <p:cBhvr>
                                         <p:cTn id="22" dur="500"/>
                                         <p:tgtEl>
-                                          <p:spTgt spid="21"/>
+                                          <p:spTgt spid="19"/>
                                         </p:tgtEl>
                                       </p:cBhvr>
                                     </p:animEffect>
@@ -10521,7 +10054,7 @@
                                           </p:stCondLst>
                                         </p:cTn>
                                         <p:tgtEl>
-                                          <p:spTgt spid="22"/>
+                                          <p:spTgt spid="20"/>
                                         </p:tgtEl>
                                         <p:attrNameLst>
                                           <p:attrName>style.visibility</p:attrName>
@@ -10535,7 +10068,7 @@
                                       <p:cBhvr>
                                         <p:cTn id="27" dur="500"/>
                                         <p:tgtEl>
-                                          <p:spTgt spid="22"/>
+                                          <p:spTgt spid="20"/>
                                         </p:tgtEl>
                                       </p:cBhvr>
                                     </p:animEffect>
@@ -10556,7 +10089,7 @@
                                           </p:stCondLst>
                                         </p:cTn>
                                         <p:tgtEl>
-                                          <p:spTgt spid="23"/>
+                                          <p:spTgt spid="21"/>
                                         </p:tgtEl>
                                         <p:attrNameLst>
                                           <p:attrName>style.visibility</p:attrName>
@@ -10570,7 +10103,7 @@
                                       <p:cBhvr>
                                         <p:cTn id="30" dur="500"/>
                                         <p:tgtEl>
-                                          <p:spTgt spid="23"/>
+                                          <p:spTgt spid="21"/>
                                         </p:tgtEl>
                                       </p:cBhvr>
                                     </p:animEffect>
@@ -10591,7 +10124,7 @@
                                           </p:stCondLst>
                                         </p:cTn>
                                         <p:tgtEl>
-                                          <p:spTgt spid="24"/>
+                                          <p:spTgt spid="22"/>
                                         </p:tgtEl>
                                         <p:attrNameLst>
                                           <p:attrName>style.visibility</p:attrName>
@@ -10605,7 +10138,7 @@
                                       <p:cBhvr>
                                         <p:cTn id="33" dur="500"/>
                                         <p:tgtEl>
-                                          <p:spTgt spid="24"/>
+                                          <p:spTgt spid="22"/>
                                         </p:tgtEl>
                                       </p:cBhvr>
                                     </p:animEffect>
@@ -10626,7 +10159,7 @@
                                           </p:stCondLst>
                                         </p:cTn>
                                         <p:tgtEl>
-                                          <p:spTgt spid="25"/>
+                                          <p:spTgt spid="23"/>
                                         </p:tgtEl>
                                         <p:attrNameLst>
                                           <p:attrName>style.visibility</p:attrName>
@@ -10640,42 +10173,7 @@
                                       <p:cBhvr>
                                         <p:cTn id="36" dur="500"/>
                                         <p:tgtEl>
-                                          <p:spTgt spid="25"/>
-                                        </p:tgtEl>
-                                      </p:cBhvr>
-                                    </p:animEffect>
-                                  </p:childTnLst>
-                                </p:cTn>
-                              </p:par>
-                              <p:par>
-                                <p:cTn id="37" presetID="10" presetClass="entr" presetSubtype="0" fill="hold" grpId="0" nodeType="withEffect">
-                                  <p:stCondLst>
-                                    <p:cond delay="0"/>
-                                  </p:stCondLst>
-                                  <p:childTnLst>
-                                    <p:set>
-                                      <p:cBhvr>
-                                        <p:cTn id="38" dur="1" fill="hold">
-                                          <p:stCondLst>
-                                            <p:cond delay="0"/>
-                                          </p:stCondLst>
-                                        </p:cTn>
-                                        <p:tgtEl>
-                                          <p:spTgt spid="26"/>
-                                        </p:tgtEl>
-                                        <p:attrNameLst>
-                                          <p:attrName>style.visibility</p:attrName>
-                                        </p:attrNameLst>
-                                      </p:cBhvr>
-                                      <p:to>
-                                        <p:strVal val="visible"/>
-                                      </p:to>
-                                    </p:set>
-                                    <p:animEffect transition="in" filter="fade">
-                                      <p:cBhvr>
-                                        <p:cTn id="39" dur="500"/>
-                                        <p:tgtEl>
-                                          <p:spTgt spid="26"/>
+                                          <p:spTgt spid="23"/>
                                         </p:tgtEl>
                                       </p:cBhvr>
                                     </p:animEffect>
@@ -10689,19 +10187,54 @@
                     </p:cTn>
                   </p:par>
                   <p:par>
-                    <p:cTn id="40" fill="hold">
+                    <p:cTn id="37" fill="hold">
                       <p:stCondLst>
                         <p:cond delay="indefinite"/>
                       </p:stCondLst>
                       <p:childTnLst>
                         <p:par>
-                          <p:cTn id="41" fill="hold">
+                          <p:cTn id="38" fill="hold">
                             <p:stCondLst>
                               <p:cond delay="0"/>
                             </p:stCondLst>
                             <p:childTnLst>
                               <p:par>
-                                <p:cTn id="42" presetID="10" presetClass="entr" presetSubtype="0" fill="hold" nodeType="clickEffect">
+                                <p:cTn id="39" presetID="10" presetClass="entr" presetSubtype="0" fill="hold" nodeType="clickEffect">
+                                  <p:stCondLst>
+                                    <p:cond delay="0"/>
+                                  </p:stCondLst>
+                                  <p:childTnLst>
+                                    <p:set>
+                                      <p:cBhvr>
+                                        <p:cTn id="40" dur="1" fill="hold">
+                                          <p:stCondLst>
+                                            <p:cond delay="0"/>
+                                          </p:stCondLst>
+                                        </p:cTn>
+                                        <p:tgtEl>
+                                          <p:spTgt spid="24"/>
+                                        </p:tgtEl>
+                                        <p:attrNameLst>
+                                          <p:attrName>style.visibility</p:attrName>
+                                        </p:attrNameLst>
+                                      </p:cBhvr>
+                                      <p:to>
+                                        <p:strVal val="visible"/>
+                                      </p:to>
+                                    </p:set>
+                                    <p:animEffect transition="in" filter="fade">
+                                      <p:cBhvr>
+                                        <p:cTn id="41" dur="500"/>
+                                        <p:tgtEl>
+                                          <p:spTgt spid="24"/>
+                                        </p:tgtEl>
+                                      </p:cBhvr>
+                                    </p:animEffect>
+                                  </p:childTnLst>
+                                </p:cTn>
+                              </p:par>
+                              <p:par>
+                                <p:cTn id="42" presetID="10" presetClass="entr" presetSubtype="0" fill="hold" grpId="0" nodeType="withEffect">
                                   <p:stCondLst>
                                     <p:cond delay="0"/>
                                   </p:stCondLst>
@@ -10714,7 +10247,7 @@
                                           </p:stCondLst>
                                         </p:cTn>
                                         <p:tgtEl>
-                                          <p:spTgt spid="27"/>
+                                          <p:spTgt spid="25"/>
                                         </p:tgtEl>
                                         <p:attrNameLst>
                                           <p:attrName>style.visibility</p:attrName>
@@ -10728,7 +10261,7 @@
                                       <p:cBhvr>
                                         <p:cTn id="44" dur="500"/>
                                         <p:tgtEl>
-                                          <p:spTgt spid="27"/>
+                                          <p:spTgt spid="25"/>
                                         </p:tgtEl>
                                       </p:cBhvr>
                                     </p:animEffect>
@@ -10749,7 +10282,7 @@
                                           </p:stCondLst>
                                         </p:cTn>
                                         <p:tgtEl>
-                                          <p:spTgt spid="28"/>
+                                          <p:spTgt spid="26"/>
                                         </p:tgtEl>
                                         <p:attrNameLst>
                                           <p:attrName>style.visibility</p:attrName>
@@ -10763,7 +10296,7 @@
                                       <p:cBhvr>
                                         <p:cTn id="47" dur="500"/>
                                         <p:tgtEl>
-                                          <p:spTgt spid="28"/>
+                                          <p:spTgt spid="26"/>
                                         </p:tgtEl>
                                       </p:cBhvr>
                                     </p:animEffect>
@@ -10771,7 +10304,7 @@
                                 </p:cTn>
                               </p:par>
                               <p:par>
-                                <p:cTn id="48" presetID="10" presetClass="entr" presetSubtype="0" fill="hold" grpId="0" nodeType="withEffect">
+                                <p:cTn id="48" presetID="10" presetClass="entr" presetSubtype="0" fill="hold" nodeType="withEffect">
                                   <p:stCondLst>
                                     <p:cond delay="0"/>
                                   </p:stCondLst>
@@ -10784,7 +10317,7 @@
                                           </p:stCondLst>
                                         </p:cTn>
                                         <p:tgtEl>
-                                          <p:spTgt spid="29"/>
+                                          <p:spTgt spid="27"/>
                                         </p:tgtEl>
                                         <p:attrNameLst>
                                           <p:attrName>style.visibility</p:attrName>
@@ -10798,7 +10331,7 @@
                                       <p:cBhvr>
                                         <p:cTn id="50" dur="500"/>
                                         <p:tgtEl>
-                                          <p:spTgt spid="29"/>
+                                          <p:spTgt spid="27"/>
                                         </p:tgtEl>
                                       </p:cBhvr>
                                     </p:animEffect>
@@ -10806,7 +10339,7 @@
                                 </p:cTn>
                               </p:par>
                               <p:par>
-                                <p:cTn id="51" presetID="10" presetClass="entr" presetSubtype="0" fill="hold" nodeType="withEffect">
+                                <p:cTn id="51" presetID="10" presetClass="entr" presetSubtype="0" fill="hold" grpId="0" nodeType="withEffect">
                                   <p:stCondLst>
                                     <p:cond delay="0"/>
                                   </p:stCondLst>
@@ -10819,7 +10352,7 @@
                                           </p:stCondLst>
                                         </p:cTn>
                                         <p:tgtEl>
-                                          <p:spTgt spid="30"/>
+                                          <p:spTgt spid="28"/>
                                         </p:tgtEl>
                                         <p:attrNameLst>
                                           <p:attrName>style.visibility</p:attrName>
@@ -10833,77 +10366,7 @@
                                       <p:cBhvr>
                                         <p:cTn id="53" dur="500"/>
                                         <p:tgtEl>
-                                          <p:spTgt spid="30"/>
-                                        </p:tgtEl>
-                                      </p:cBhvr>
-                                    </p:animEffect>
-                                  </p:childTnLst>
-                                </p:cTn>
-                              </p:par>
-                              <p:par>
-                                <p:cTn id="54" presetID="10" presetClass="entr" presetSubtype="0" fill="hold" grpId="0" nodeType="withEffect">
-                                  <p:stCondLst>
-                                    <p:cond delay="0"/>
-                                  </p:stCondLst>
-                                  <p:childTnLst>
-                                    <p:set>
-                                      <p:cBhvr>
-                                        <p:cTn id="55" dur="1" fill="hold">
-                                          <p:stCondLst>
-                                            <p:cond delay="0"/>
-                                          </p:stCondLst>
-                                        </p:cTn>
-                                        <p:tgtEl>
-                                          <p:spTgt spid="31"/>
-                                        </p:tgtEl>
-                                        <p:attrNameLst>
-                                          <p:attrName>style.visibility</p:attrName>
-                                        </p:attrNameLst>
-                                      </p:cBhvr>
-                                      <p:to>
-                                        <p:strVal val="visible"/>
-                                      </p:to>
-                                    </p:set>
-                                    <p:animEffect transition="in" filter="fade">
-                                      <p:cBhvr>
-                                        <p:cTn id="56" dur="500"/>
-                                        <p:tgtEl>
-                                          <p:spTgt spid="31"/>
-                                        </p:tgtEl>
-                                      </p:cBhvr>
-                                    </p:animEffect>
-                                  </p:childTnLst>
-                                </p:cTn>
-                              </p:par>
-                              <p:par>
-                                <p:cTn id="57" presetID="10" presetClass="entr" presetSubtype="0" fill="hold" grpId="0" nodeType="withEffect">
-                                  <p:stCondLst>
-                                    <p:cond delay="0"/>
-                                  </p:stCondLst>
-                                  <p:childTnLst>
-                                    <p:set>
-                                      <p:cBhvr>
-                                        <p:cTn id="58" dur="1" fill="hold">
-                                          <p:stCondLst>
-                                            <p:cond delay="0"/>
-                                          </p:stCondLst>
-                                        </p:cTn>
-                                        <p:tgtEl>
-                                          <p:spTgt spid="32"/>
-                                        </p:tgtEl>
-                                        <p:attrNameLst>
-                                          <p:attrName>style.visibility</p:attrName>
-                                        </p:attrNameLst>
-                                      </p:cBhvr>
-                                      <p:to>
-                                        <p:strVal val="visible"/>
-                                      </p:to>
-                                    </p:set>
-                                    <p:animEffect transition="in" filter="fade">
-                                      <p:cBhvr>
-                                        <p:cTn id="59" dur="500"/>
-                                        <p:tgtEl>
-                                          <p:spTgt spid="32"/>
+                                          <p:spTgt spid="28"/>
                                         </p:tgtEl>
                                       </p:cBhvr>
                                     </p:animEffect>
@@ -10938,17 +10401,15 @@
       </p:par>
     </p:tnLst>
     <p:bldLst>
-      <p:bldP spid="17" grpId="0" animBg="1"/>
-      <p:bldP spid="18" grpId="0" animBg="1"/>
+      <p:bldP spid="15" grpId="0" animBg="1"/>
+      <p:bldP spid="16" grpId="0" animBg="1"/>
+      <p:bldP spid="19" grpId="0" animBg="1"/>
       <p:bldP spid="21" grpId="0" animBg="1"/>
+      <p:bldP spid="22" grpId="0" animBg="1"/>
       <p:bldP spid="23" grpId="0" animBg="1"/>
-      <p:bldP spid="24" grpId="0" animBg="1"/>
       <p:bldP spid="25" grpId="0" animBg="1"/>
       <p:bldP spid="26" grpId="0" animBg="1"/>
       <p:bldP spid="28" grpId="0" animBg="1"/>
-      <p:bldP spid="29" grpId="0" animBg="1"/>
-      <p:bldP spid="31" grpId="0" animBg="1"/>
-      <p:bldP spid="32" grpId="0" animBg="1"/>
     </p:bldLst>
   </p:timing>
 </p:sld>
@@ -11157,11 +10618,11 @@
         <p:spPr>
           <a:xfrm>
             <a:off x="548640" y="2011680"/>
-            <a:ext cx="3511296" cy="2688336"/>
+            <a:ext cx="3511296" cy="2231136"/>
           </a:xfrm>
           <a:prstGeom prst="roundRect">
             <a:avLst>
-              <a:gd name="adj" fmla="val 2721"/>
+              <a:gd name="adj" fmla="val 3279"/>
             </a:avLst>
           </a:prstGeom>
           <a:solidFill>
@@ -11623,11 +11084,11 @@
         <p:spPr>
           <a:xfrm>
             <a:off x="4334256" y="2011680"/>
-            <a:ext cx="3511296" cy="2688336"/>
+            <a:ext cx="3511296" cy="2231136"/>
           </a:xfrm>
           <a:prstGeom prst="roundRect">
             <a:avLst>
-              <a:gd name="adj" fmla="val 2721"/>
+              <a:gd name="adj" fmla="val 3279"/>
             </a:avLst>
           </a:prstGeom>
           <a:solidFill>
@@ -12023,88 +11484,7 @@
       </p:sp>
       <p:sp>
         <p:nvSpPr>
-          <p:cNvPr id="19" name="Text 16"/>
-          <p:cNvSpPr txBox="1"/>
-          <p:nvPr/>
-        </p:nvSpPr>
-        <p:spPr>
-          <a:xfrm>
-            <a:off x="4517136" y="4041648"/>
-            <a:ext cx="3236976" cy="457200"/>
-          </a:xfrm>
-          <a:prstGeom prst="rect">
-            <a:avLst/>
-          </a:prstGeom>
-          <a:noFill/>
-          <a:ln/>
-        </p:spPr>
-        <p:txBody>
-          <a:bodyPr wrap="square" lIns="0" tIns="0" rIns="0" bIns="0" rtlCol="0" anchor="ctr"/>
-          <a:lstStyle/>
-          <a:p>
-            <a:pPr indent="0" marL="0">
-              <a:buNone/>
-            </a:pPr>
-            <a:r>
-              <a:rPr lang="en-US" sz="2000" dirty="0">
-                <a:solidFill>
-                  <a:srgbClr val="E8C878"/>
-                </a:solidFill>
-                <a:latin typeface="Consolas" pitchFamily="34" charset="0"/>
-                <a:ea typeface="Consolas" pitchFamily="34" charset="-122"/>
-                <a:cs typeface="Consolas" pitchFamily="34" charset="-120"/>
-              </a:rPr>
-              <a:t>print</a:t>
-            </a:r>
-            <a:pPr indent="0" marL="0">
-              <a:buNone/>
-            </a:pPr>
-            <a:r>
-              <a:rPr lang="en-US" sz="2000" dirty="0">
-                <a:solidFill>
-                  <a:srgbClr val="A9A9B4"/>
-                </a:solidFill>
-                <a:latin typeface="Consolas" pitchFamily="34" charset="0"/>
-                <a:ea typeface="Consolas" pitchFamily="34" charset="-122"/>
-                <a:cs typeface="Consolas" pitchFamily="34" charset="-120"/>
-              </a:rPr>
-              <a:t>(</a:t>
-            </a:r>
-            <a:pPr indent="0" marL="0">
-              <a:buNone/>
-            </a:pPr>
-            <a:r>
-              <a:rPr lang="en-US" sz="2000" dirty="0">
-                <a:solidFill>
-                  <a:srgbClr val="E69F00"/>
-                </a:solidFill>
-                <a:latin typeface="Consolas" pitchFamily="34" charset="0"/>
-                <a:ea typeface="Consolas" pitchFamily="34" charset="-122"/>
-                <a:cs typeface="Consolas" pitchFamily="34" charset="-120"/>
-              </a:rPr>
-              <a:t>"Scan done"</a:t>
-            </a:r>
-            <a:pPr indent="0" marL="0">
-              <a:buNone/>
-            </a:pPr>
-            <a:r>
-              <a:rPr lang="en-US" sz="2000" dirty="0">
-                <a:solidFill>
-                  <a:srgbClr val="A9A9B4"/>
-                </a:solidFill>
-                <a:latin typeface="Consolas" pitchFamily="34" charset="0"/>
-                <a:ea typeface="Consolas" pitchFamily="34" charset="-122"/>
-                <a:cs typeface="Consolas" pitchFamily="34" charset="-120"/>
-              </a:rPr>
-              <a:t>)</a:t>
-            </a:r>
-            <a:endParaRPr lang="en-US" sz="2000" dirty="0"/>
-          </a:p>
-        </p:txBody>
-      </p:sp>
-      <p:sp>
-        <p:nvSpPr>
-          <p:cNvPr id="20" name="Shape 17"/>
+          <p:cNvPr id="19" name="Shape 16"/>
           <p:cNvSpPr/>
           <p:nvPr/>
         </p:nvSpPr>
@@ -12124,7 +11504,7 @@
       </p:sp>
       <p:sp>
         <p:nvSpPr>
-          <p:cNvPr id="21" name="Text 18"/>
+          <p:cNvPr id="20" name="Text 17"/>
           <p:cNvSpPr txBox="1"/>
           <p:nvPr/>
         </p:nvSpPr>
@@ -12163,18 +11543,18 @@
       </p:sp>
       <p:sp>
         <p:nvSpPr>
-          <p:cNvPr id="22" name="code"/>
+          <p:cNvPr id="21" name="code"/>
           <p:cNvSpPr/>
           <p:nvPr/>
         </p:nvSpPr>
         <p:spPr>
           <a:xfrm>
             <a:off x="8119872" y="2011680"/>
-            <a:ext cx="3511296" cy="2688336"/>
+            <a:ext cx="3511296" cy="2231136"/>
           </a:xfrm>
           <a:prstGeom prst="roundRect">
             <a:avLst>
-              <a:gd name="adj" fmla="val 2721"/>
+              <a:gd name="adj" fmla="val 3279"/>
             </a:avLst>
           </a:prstGeom>
           <a:solidFill>
@@ -12190,7 +11570,7 @@
       </p:sp>
       <p:sp>
         <p:nvSpPr>
-          <p:cNvPr id="23" name="Text 20"/>
+          <p:cNvPr id="22" name="Text 19"/>
           <p:cNvSpPr txBox="1"/>
           <p:nvPr/>
         </p:nvSpPr>
@@ -12327,7 +11707,7 @@
       </p:sp>
       <p:sp>
         <p:nvSpPr>
-          <p:cNvPr id="24" name="Text 21"/>
+          <p:cNvPr id="23" name="Text 20"/>
           <p:cNvSpPr txBox="1"/>
           <p:nvPr/>
         </p:nvSpPr>
@@ -12422,7 +11802,7 @@
       </p:sp>
       <p:sp>
         <p:nvSpPr>
-          <p:cNvPr id="25" name="Text 22"/>
+          <p:cNvPr id="24" name="Text 21"/>
           <p:cNvSpPr txBox="1"/>
           <p:nvPr/>
         </p:nvSpPr>
@@ -12475,7 +11855,7 @@
       </p:sp>
       <p:sp>
         <p:nvSpPr>
-          <p:cNvPr id="26" name="Text 23"/>
+          <p:cNvPr id="25" name="Text 22"/>
           <p:cNvSpPr txBox="1"/>
           <p:nvPr/>
         </p:nvSpPr>
@@ -12570,94 +11950,13 @@
       </p:sp>
       <p:sp>
         <p:nvSpPr>
-          <p:cNvPr id="27" name="Text 24"/>
-          <p:cNvSpPr txBox="1"/>
-          <p:nvPr/>
-        </p:nvSpPr>
-        <p:spPr>
-          <a:xfrm>
-            <a:off x="8302752" y="4041648"/>
-            <a:ext cx="3236976" cy="457200"/>
-          </a:xfrm>
-          <a:prstGeom prst="rect">
-            <a:avLst/>
-          </a:prstGeom>
-          <a:noFill/>
-          <a:ln/>
-        </p:spPr>
-        <p:txBody>
-          <a:bodyPr wrap="square" lIns="0" tIns="0" rIns="0" bIns="0" rtlCol="0" anchor="ctr"/>
-          <a:lstStyle/>
-          <a:p>
-            <a:pPr indent="0" marL="0">
-              <a:buNone/>
-            </a:pPr>
-            <a:r>
-              <a:rPr lang="en-US" sz="2000" dirty="0">
-                <a:solidFill>
-                  <a:srgbClr val="E8C878"/>
-                </a:solidFill>
-                <a:latin typeface="Consolas" pitchFamily="34" charset="0"/>
-                <a:ea typeface="Consolas" pitchFamily="34" charset="-122"/>
-                <a:cs typeface="Consolas" pitchFamily="34" charset="-120"/>
-              </a:rPr>
-              <a:t>print</a:t>
-            </a:r>
-            <a:pPr indent="0" marL="0">
-              <a:buNone/>
-            </a:pPr>
-            <a:r>
-              <a:rPr lang="en-US" sz="2000" dirty="0">
-                <a:solidFill>
-                  <a:srgbClr val="A9A9B4"/>
-                </a:solidFill>
-                <a:latin typeface="Consolas" pitchFamily="34" charset="0"/>
-                <a:ea typeface="Consolas" pitchFamily="34" charset="-122"/>
-                <a:cs typeface="Consolas" pitchFamily="34" charset="-120"/>
-              </a:rPr>
-              <a:t>(</a:t>
-            </a:r>
-            <a:pPr indent="0" marL="0">
-              <a:buNone/>
-            </a:pPr>
-            <a:r>
-              <a:rPr lang="en-US" sz="2000" dirty="0">
-                <a:solidFill>
-                  <a:srgbClr val="E69F00"/>
-                </a:solidFill>
-                <a:latin typeface="Consolas" pitchFamily="34" charset="0"/>
-                <a:ea typeface="Consolas" pitchFamily="34" charset="-122"/>
-                <a:cs typeface="Consolas" pitchFamily="34" charset="-120"/>
-              </a:rPr>
-              <a:t>"End"</a:t>
-            </a:r>
-            <a:pPr indent="0" marL="0">
-              <a:buNone/>
-            </a:pPr>
-            <a:r>
-              <a:rPr lang="en-US" sz="2000" dirty="0">
-                <a:solidFill>
-                  <a:srgbClr val="A9A9B4"/>
-                </a:solidFill>
-                <a:latin typeface="Consolas" pitchFamily="34" charset="0"/>
-                <a:ea typeface="Consolas" pitchFamily="34" charset="-122"/>
-                <a:cs typeface="Consolas" pitchFamily="34" charset="-120"/>
-              </a:rPr>
-              <a:t>)</a:t>
-            </a:r>
-            <a:endParaRPr lang="en-US" sz="2000" dirty="0"/>
-          </a:p>
-        </p:txBody>
-      </p:sp>
-      <p:sp>
-        <p:nvSpPr>
-          <p:cNvPr id="28" name="Shape 25"/>
+          <p:cNvPr id="26" name="Shape 23"/>
           <p:cNvSpPr/>
           <p:nvPr/>
         </p:nvSpPr>
         <p:spPr>
           <a:xfrm>
-            <a:off x="548640" y="5020056"/>
+            <a:off x="548640" y="4562856"/>
             <a:ext cx="11091672" cy="914400"/>
           </a:xfrm>
           <a:prstGeom prst="roundRect">
@@ -12678,13 +11977,13 @@
       </p:sp>
       <p:sp>
         <p:nvSpPr>
-          <p:cNvPr id="29" name="Text 26"/>
-          <p:cNvSpPr txBox="1"/>
-          <p:nvPr/>
-        </p:nvSpPr>
-        <p:spPr>
-          <a:xfrm>
-            <a:off x="914400" y="5020056"/>
+          <p:cNvPr id="27" name="Text 24"/>
+          <p:cNvSpPr txBox="1"/>
+          <p:nvPr/>
+        </p:nvSpPr>
+        <p:spPr>
+          <a:xfrm>
+            <a:off x="914400" y="4562856"/>
             <a:ext cx="10332720" cy="914400"/>
           </a:xfrm>
           <a:prstGeom prst="rect">
@@ -12731,7 +12030,7 @@
       </p:sp>
       <p:sp>
         <p:nvSpPr>
-          <p:cNvPr id="30" name="Shape 27"/>
+          <p:cNvPr id="28" name="Shape 25"/>
           <p:cNvSpPr/>
           <p:nvPr/>
         </p:nvSpPr>
@@ -12758,7 +12057,7 @@
       </p:sp>
       <p:sp>
         <p:nvSpPr>
-          <p:cNvPr id="31" name="Text 28"/>
+          <p:cNvPr id="29" name="Text 26"/>
           <p:cNvSpPr txBox="1"/>
           <p:nvPr/>
         </p:nvSpPr>
@@ -12797,7 +12096,7 @@
       </p:sp>
       <p:sp>
         <p:nvSpPr>
-          <p:cNvPr id="32" name="Shape 29"/>
+          <p:cNvPr id="30" name="Shape 27"/>
           <p:cNvSpPr/>
           <p:nvPr/>
         </p:nvSpPr>
@@ -12819,7 +12118,7 @@
       </p:sp>
       <p:sp>
         <p:nvSpPr>
-          <p:cNvPr id="33" name="Text 30"/>
+          <p:cNvPr id="31" name="Text 28"/>
           <p:cNvSpPr txBox="1"/>
           <p:nvPr/>
         </p:nvSpPr>
@@ -12858,7 +12157,7 @@
       </p:sp>
       <p:pic>
         <p:nvPicPr>
-          <p:cNvPr id="34" name="Image 1" descr="Deliberate practice">    </p:cNvPr>
+          <p:cNvPr id="32" name="Image 1" descr="Deliberate practice">    </p:cNvPr>
           <p:cNvPicPr>
             <a:picLocks noChangeAspect="1"/>
           </p:cNvPicPr>
@@ -12882,7 +12181,7 @@
       </p:pic>
       <p:sp>
         <p:nvSpPr>
-          <p:cNvPr id="25" name="Slide Number Placeholder 0"/>
+          <p:cNvPr id="33" name="Slide Number Placeholder 0"/>
           <p:cNvSpPr>
             <a:spLocks noGrp="1"/>
           </p:cNvSpPr>
@@ -13192,11 +12491,11 @@
         <p:spPr>
           <a:xfrm>
             <a:off x="548640" y="2011680"/>
-            <a:ext cx="3511296" cy="2688336"/>
+            <a:ext cx="3511296" cy="2231136"/>
           </a:xfrm>
           <a:prstGeom prst="roundRect">
             <a:avLst>
-              <a:gd name="adj" fmla="val 2721"/>
+              <a:gd name="adj" fmla="val 3279"/>
             </a:avLst>
           </a:prstGeom>
           <a:solidFill>
@@ -13598,7 +12897,7 @@
         </p:nvSpPr>
         <p:spPr>
           <a:xfrm>
-            <a:off x="548640" y="4882896"/>
+            <a:off x="548640" y="4425696"/>
             <a:ext cx="3511296" cy="822960"/>
           </a:xfrm>
           <a:prstGeom prst="roundRect">
@@ -13625,7 +12924,7 @@
         </p:nvSpPr>
         <p:spPr>
           <a:xfrm>
-            <a:off x="777240" y="5111496"/>
+            <a:off x="777240" y="4654296"/>
             <a:ext cx="3054096" cy="365760"/>
           </a:xfrm>
           <a:prstGeom prst="rect">
@@ -13777,11 +13076,11 @@
         <p:spPr>
           <a:xfrm>
             <a:off x="4334256" y="2011680"/>
-            <a:ext cx="3511296" cy="2688336"/>
+            <a:ext cx="3511296" cy="2231136"/>
           </a:xfrm>
           <a:prstGeom prst="roundRect">
             <a:avLst>
-              <a:gd name="adj" fmla="val 2721"/>
+              <a:gd name="adj" fmla="val 3279"/>
             </a:avLst>
           </a:prstGeom>
           <a:solidFill>
@@ -14177,99 +13476,18 @@
       </p:sp>
       <p:sp>
         <p:nvSpPr>
-          <p:cNvPr id="23" name="Text 20"/>
-          <p:cNvSpPr txBox="1"/>
-          <p:nvPr/>
-        </p:nvSpPr>
-        <p:spPr>
-          <a:xfrm>
-            <a:off x="4517136" y="4041648"/>
-            <a:ext cx="3236976" cy="457200"/>
-          </a:xfrm>
-          <a:prstGeom prst="rect">
-            <a:avLst/>
-          </a:prstGeom>
-          <a:noFill/>
-          <a:ln/>
-        </p:spPr>
-        <p:txBody>
-          <a:bodyPr wrap="square" lIns="0" tIns="0" rIns="0" bIns="0" rtlCol="0" anchor="ctr"/>
-          <a:lstStyle/>
-          <a:p>
-            <a:pPr indent="0" marL="0">
-              <a:buNone/>
-            </a:pPr>
-            <a:r>
-              <a:rPr lang="en-US" sz="2000" dirty="0">
-                <a:solidFill>
-                  <a:srgbClr val="E8C878"/>
-                </a:solidFill>
-                <a:latin typeface="Consolas" pitchFamily="34" charset="0"/>
-                <a:ea typeface="Consolas" pitchFamily="34" charset="-122"/>
-                <a:cs typeface="Consolas" pitchFamily="34" charset="-120"/>
-              </a:rPr>
-              <a:t>print</a:t>
-            </a:r>
-            <a:pPr indent="0" marL="0">
-              <a:buNone/>
-            </a:pPr>
-            <a:r>
-              <a:rPr lang="en-US" sz="2000" dirty="0">
-                <a:solidFill>
-                  <a:srgbClr val="A9A9B4"/>
-                </a:solidFill>
-                <a:latin typeface="Consolas" pitchFamily="34" charset="0"/>
-                <a:ea typeface="Consolas" pitchFamily="34" charset="-122"/>
-                <a:cs typeface="Consolas" pitchFamily="34" charset="-120"/>
-              </a:rPr>
-              <a:t>(</a:t>
-            </a:r>
-            <a:pPr indent="0" marL="0">
-              <a:buNone/>
-            </a:pPr>
-            <a:r>
-              <a:rPr lang="en-US" sz="2000" dirty="0">
-                <a:solidFill>
-                  <a:srgbClr val="E69F00"/>
-                </a:solidFill>
-                <a:latin typeface="Consolas" pitchFamily="34" charset="0"/>
-                <a:ea typeface="Consolas" pitchFamily="34" charset="-122"/>
-                <a:cs typeface="Consolas" pitchFamily="34" charset="-120"/>
-              </a:rPr>
-              <a:t>"Scan done"</a:t>
-            </a:r>
-            <a:pPr indent="0" marL="0">
-              <a:buNone/>
-            </a:pPr>
-            <a:r>
-              <a:rPr lang="en-US" sz="2000" dirty="0">
-                <a:solidFill>
-                  <a:srgbClr val="A9A9B4"/>
-                </a:solidFill>
-                <a:latin typeface="Consolas" pitchFamily="34" charset="0"/>
-                <a:ea typeface="Consolas" pitchFamily="34" charset="-122"/>
-                <a:cs typeface="Consolas" pitchFamily="34" charset="-120"/>
-              </a:rPr>
-              <a:t>)</a:t>
-            </a:r>
-            <a:endParaRPr lang="en-US" sz="2000" dirty="0"/>
-          </a:p>
-        </p:txBody>
-      </p:sp>
-      <p:sp>
-        <p:nvSpPr>
-          <p:cNvPr id="24" name="terminal"/>
+          <p:cNvPr id="23" name="terminal"/>
           <p:cNvSpPr/>
           <p:nvPr/>
         </p:nvSpPr>
         <p:spPr>
           <a:xfrm>
-            <a:off x="4334256" y="4882896"/>
-            <a:ext cx="3511296" cy="1188720"/>
+            <a:off x="4334256" y="4425696"/>
+            <a:ext cx="3511296" cy="822960"/>
           </a:xfrm>
           <a:prstGeom prst="roundRect">
             <a:avLst>
-              <a:gd name="adj" fmla="val 6154"/>
+              <a:gd name="adj" fmla="val 8889"/>
             </a:avLst>
           </a:prstGeom>
           <a:solidFill>
@@ -14285,13 +13503,13 @@
       </p:sp>
       <p:sp>
         <p:nvSpPr>
-          <p:cNvPr id="25" name="Text 22"/>
-          <p:cNvSpPr txBox="1"/>
-          <p:nvPr/>
-        </p:nvSpPr>
-        <p:spPr>
-          <a:xfrm>
-            <a:off x="4562856" y="5111496"/>
+          <p:cNvPr id="24" name="Text 21"/>
+          <p:cNvSpPr txBox="1"/>
+          <p:nvPr/>
+        </p:nvSpPr>
+        <p:spPr>
+          <a:xfrm>
+            <a:off x="4562856" y="4654296"/>
             <a:ext cx="3054096" cy="365760"/>
           </a:xfrm>
           <a:prstGeom prst="rect">
@@ -14324,46 +13542,7 @@
       </p:sp>
       <p:sp>
         <p:nvSpPr>
-          <p:cNvPr id="26" name="Text 23"/>
-          <p:cNvSpPr txBox="1"/>
-          <p:nvPr/>
-        </p:nvSpPr>
-        <p:spPr>
-          <a:xfrm>
-            <a:off x="4562856" y="5477256"/>
-            <a:ext cx="3054096" cy="365760"/>
-          </a:xfrm>
-          <a:prstGeom prst="rect">
-            <a:avLst/>
-          </a:prstGeom>
-          <a:noFill/>
-          <a:ln/>
-        </p:spPr>
-        <p:txBody>
-          <a:bodyPr wrap="square" lIns="0" tIns="0" rIns="0" bIns="0" rtlCol="0" anchor="ctr"/>
-          <a:lstStyle/>
-          <a:p>
-            <a:pPr indent="0" marL="0">
-              <a:buNone/>
-            </a:pPr>
-            <a:r>
-              <a:rPr lang="en-US" sz="1800" dirty="0">
-                <a:solidFill>
-                  <a:srgbClr val="F5F5F3"/>
-                </a:solidFill>
-                <a:latin typeface="Consolas" pitchFamily="34" charset="0"/>
-                <a:ea typeface="Consolas" pitchFamily="34" charset="-122"/>
-                <a:cs typeface="Consolas" pitchFamily="34" charset="-120"/>
-              </a:rPr>
-              <a:t>Scan done</a:t>
-            </a:r>
-            <a:endParaRPr lang="en-US" sz="1800" dirty="0"/>
-          </a:p>
-        </p:txBody>
-      </p:sp>
-      <p:sp>
-        <p:nvSpPr>
-          <p:cNvPr id="27" name="Shape 24"/>
+          <p:cNvPr id="25" name="Shape 22"/>
           <p:cNvSpPr/>
           <p:nvPr/>
         </p:nvSpPr>
@@ -14383,7 +13562,7 @@
       </p:sp>
       <p:sp>
         <p:nvSpPr>
-          <p:cNvPr id="28" name="Text 25"/>
+          <p:cNvPr id="26" name="Text 23"/>
           <p:cNvSpPr txBox="1"/>
           <p:nvPr/>
         </p:nvSpPr>
@@ -14422,7 +13601,7 @@
       </p:sp>
       <p:sp>
         <p:nvSpPr>
-          <p:cNvPr id="29" name="Text 26"/>
+          <p:cNvPr id="27" name="Text 24"/>
           <p:cNvSpPr txBox="1"/>
           <p:nvPr/>
         </p:nvSpPr>
@@ -14475,18 +13654,18 @@
       </p:sp>
       <p:sp>
         <p:nvSpPr>
-          <p:cNvPr id="30" name="code"/>
+          <p:cNvPr id="28" name="code"/>
           <p:cNvSpPr/>
           <p:nvPr/>
         </p:nvSpPr>
         <p:spPr>
           <a:xfrm>
             <a:off x="8119872" y="2011680"/>
-            <a:ext cx="3511296" cy="2688336"/>
+            <a:ext cx="3511296" cy="2231136"/>
           </a:xfrm>
           <a:prstGeom prst="roundRect">
             <a:avLst>
-              <a:gd name="adj" fmla="val 2721"/>
+              <a:gd name="adj" fmla="val 3279"/>
             </a:avLst>
           </a:prstGeom>
           <a:solidFill>
@@ -14502,7 +13681,7 @@
       </p:sp>
       <p:sp>
         <p:nvSpPr>
-          <p:cNvPr id="31" name="Text 28"/>
+          <p:cNvPr id="29" name="Text 26"/>
           <p:cNvSpPr txBox="1"/>
           <p:nvPr/>
         </p:nvSpPr>
@@ -14639,7 +13818,7 @@
       </p:sp>
       <p:sp>
         <p:nvSpPr>
-          <p:cNvPr id="32" name="Text 29"/>
+          <p:cNvPr id="30" name="Text 27"/>
           <p:cNvSpPr txBox="1"/>
           <p:nvPr/>
         </p:nvSpPr>
@@ -14734,7 +13913,7 @@
       </p:sp>
       <p:sp>
         <p:nvSpPr>
-          <p:cNvPr id="33" name="Text 30"/>
+          <p:cNvPr id="31" name="Text 28"/>
           <p:cNvSpPr txBox="1"/>
           <p:nvPr/>
         </p:nvSpPr>
@@ -14787,7 +13966,7 @@
       </p:sp>
       <p:sp>
         <p:nvSpPr>
-          <p:cNvPr id="34" name="Text 31"/>
+          <p:cNvPr id="32" name="Text 29"/>
           <p:cNvSpPr txBox="1"/>
           <p:nvPr/>
         </p:nvSpPr>
@@ -14882,99 +14061,18 @@
       </p:sp>
       <p:sp>
         <p:nvSpPr>
-          <p:cNvPr id="35" name="Text 32"/>
-          <p:cNvSpPr txBox="1"/>
-          <p:nvPr/>
-        </p:nvSpPr>
-        <p:spPr>
-          <a:xfrm>
-            <a:off x="8302752" y="4041648"/>
-            <a:ext cx="3236976" cy="457200"/>
-          </a:xfrm>
-          <a:prstGeom prst="rect">
-            <a:avLst/>
-          </a:prstGeom>
-          <a:noFill/>
-          <a:ln/>
-        </p:spPr>
-        <p:txBody>
-          <a:bodyPr wrap="square" lIns="0" tIns="0" rIns="0" bIns="0" rtlCol="0" anchor="ctr"/>
-          <a:lstStyle/>
-          <a:p>
-            <a:pPr indent="0" marL="0">
-              <a:buNone/>
-            </a:pPr>
-            <a:r>
-              <a:rPr lang="en-US" sz="2000" dirty="0">
-                <a:solidFill>
-                  <a:srgbClr val="E8C878"/>
-                </a:solidFill>
-                <a:latin typeface="Consolas" pitchFamily="34" charset="0"/>
-                <a:ea typeface="Consolas" pitchFamily="34" charset="-122"/>
-                <a:cs typeface="Consolas" pitchFamily="34" charset="-120"/>
-              </a:rPr>
-              <a:t>print</a:t>
-            </a:r>
-            <a:pPr indent="0" marL="0">
-              <a:buNone/>
-            </a:pPr>
-            <a:r>
-              <a:rPr lang="en-US" sz="2000" dirty="0">
-                <a:solidFill>
-                  <a:srgbClr val="A9A9B4"/>
-                </a:solidFill>
-                <a:latin typeface="Consolas" pitchFamily="34" charset="0"/>
-                <a:ea typeface="Consolas" pitchFamily="34" charset="-122"/>
-                <a:cs typeface="Consolas" pitchFamily="34" charset="-120"/>
-              </a:rPr>
-              <a:t>(</a:t>
-            </a:r>
-            <a:pPr indent="0" marL="0">
-              <a:buNone/>
-            </a:pPr>
-            <a:r>
-              <a:rPr lang="en-US" sz="2000" dirty="0">
-                <a:solidFill>
-                  <a:srgbClr val="E69F00"/>
-                </a:solidFill>
-                <a:latin typeface="Consolas" pitchFamily="34" charset="0"/>
-                <a:ea typeface="Consolas" pitchFamily="34" charset="-122"/>
-                <a:cs typeface="Consolas" pitchFamily="34" charset="-120"/>
-              </a:rPr>
-              <a:t>"End"</a:t>
-            </a:r>
-            <a:pPr indent="0" marL="0">
-              <a:buNone/>
-            </a:pPr>
-            <a:r>
-              <a:rPr lang="en-US" sz="2000" dirty="0">
-                <a:solidFill>
-                  <a:srgbClr val="A9A9B4"/>
-                </a:solidFill>
-                <a:latin typeface="Consolas" pitchFamily="34" charset="0"/>
-                <a:ea typeface="Consolas" pitchFamily="34" charset="-122"/>
-                <a:cs typeface="Consolas" pitchFamily="34" charset="-120"/>
-              </a:rPr>
-              <a:t>)</a:t>
-            </a:r>
-            <a:endParaRPr lang="en-US" sz="2000" dirty="0"/>
-          </a:p>
-        </p:txBody>
-      </p:sp>
-      <p:sp>
-        <p:nvSpPr>
-          <p:cNvPr id="36" name="terminal"/>
+          <p:cNvPr id="33" name="terminal"/>
           <p:cNvSpPr/>
           <p:nvPr/>
         </p:nvSpPr>
         <p:spPr>
           <a:xfrm>
-            <a:off x="8119872" y="4882896"/>
-            <a:ext cx="3511296" cy="1188720"/>
+            <a:off x="8119872" y="4425696"/>
+            <a:ext cx="3511296" cy="822960"/>
           </a:xfrm>
           <a:prstGeom prst="roundRect">
             <a:avLst>
-              <a:gd name="adj" fmla="val 6154"/>
+              <a:gd name="adj" fmla="val 8889"/>
             </a:avLst>
           </a:prstGeom>
           <a:solidFill>
@@ -14990,13 +14088,13 @@
       </p:sp>
       <p:sp>
         <p:nvSpPr>
-          <p:cNvPr id="37" name="Text 34"/>
-          <p:cNvSpPr txBox="1"/>
-          <p:nvPr/>
-        </p:nvSpPr>
-        <p:spPr>
-          <a:xfrm>
-            <a:off x="8348472" y="5111496"/>
+          <p:cNvPr id="34" name="Text 31"/>
+          <p:cNvSpPr txBox="1"/>
+          <p:nvPr/>
+        </p:nvSpPr>
+        <p:spPr>
+          <a:xfrm>
+            <a:off x="8348472" y="4654296"/>
             <a:ext cx="3054096" cy="365760"/>
           </a:xfrm>
           <a:prstGeom prst="rect">
@@ -15022,45 +14120,6 @@
                 <a:cs typeface="Consolas" pitchFamily="34" charset="-120"/>
               </a:rPr>
               <a:t>Ready</a:t>
-            </a:r>
-            <a:endParaRPr lang="en-US" sz="1800" dirty="0"/>
-          </a:p>
-        </p:txBody>
-      </p:sp>
-      <p:sp>
-        <p:nvSpPr>
-          <p:cNvPr id="38" name="Text 35"/>
-          <p:cNvSpPr txBox="1"/>
-          <p:nvPr/>
-        </p:nvSpPr>
-        <p:spPr>
-          <a:xfrm>
-            <a:off x="8348472" y="5477256"/>
-            <a:ext cx="3054096" cy="365760"/>
-          </a:xfrm>
-          <a:prstGeom prst="rect">
-            <a:avLst/>
-          </a:prstGeom>
-          <a:noFill/>
-          <a:ln/>
-        </p:spPr>
-        <p:txBody>
-          <a:bodyPr wrap="square" lIns="0" tIns="0" rIns="0" bIns="0" rtlCol="0" anchor="ctr"/>
-          <a:lstStyle/>
-          <a:p>
-            <a:pPr indent="0" marL="0">
-              <a:buNone/>
-            </a:pPr>
-            <a:r>
-              <a:rPr lang="en-US" sz="1800" dirty="0">
-                <a:solidFill>
-                  <a:srgbClr val="F5F5F3"/>
-                </a:solidFill>
-                <a:latin typeface="Consolas" pitchFamily="34" charset="0"/>
-                <a:ea typeface="Consolas" pitchFamily="34" charset="-122"/>
-                <a:cs typeface="Consolas" pitchFamily="34" charset="-120"/>
-              </a:rPr>
-              <a:t>End</a:t>
             </a:r>
             <a:endParaRPr lang="en-US" sz="1800" dirty="0"/>
           </a:p>
@@ -15068,7 +14127,7 @@
       </p:sp>
       <p:pic>
         <p:nvPicPr>
-          <p:cNvPr id="39" name="Image 1" descr="Feedback">    </p:cNvPr>
+          <p:cNvPr id="35" name="Image 1" descr="Feedback">    </p:cNvPr>
           <p:cNvPicPr>
             <a:picLocks noChangeAspect="1"/>
           </p:cNvPicPr>
@@ -15092,7 +14151,7 @@
       </p:pic>
       <p:sp>
         <p:nvSpPr>
-          <p:cNvPr id="25" name="Slide Number Placeholder 0"/>
+          <p:cNvPr id="36" name="Slide Number Placeholder 0"/>
           <p:cNvSpPr>
             <a:spLocks noGrp="1"/>
           </p:cNvSpPr>
@@ -18343,7 +17402,7 @@
       </p:pic>
       <p:sp>
         <p:nvSpPr>
-          <p:cNvPr id="25" name="Slide Number Placeholder 0"/>
+          <p:cNvPr id="57" name="Slide Number Placeholder 0"/>
           <p:cNvSpPr>
             <a:spLocks noGrp="1"/>
           </p:cNvSpPr>
@@ -21582,7 +20641,7 @@
       </p:pic>
       <p:sp>
         <p:nvSpPr>
-          <p:cNvPr id="25" name="Slide Number Placeholder 0"/>
+          <p:cNvPr id="57" name="Slide Number Placeholder 0"/>
           <p:cNvSpPr>
             <a:spLocks noGrp="1"/>
           </p:cNvSpPr>
@@ -24772,7 +23831,7 @@
       </p:pic>
       <p:sp>
         <p:nvSpPr>
-          <p:cNvPr id="25" name="Slide Number Placeholder 0"/>
+          <p:cNvPr id="38" name="Slide Number Placeholder 0"/>
           <p:cNvSpPr>
             <a:spLocks noGrp="1"/>
           </p:cNvSpPr>
@@ -27267,7 +26326,7 @@
       </p:pic>
       <p:sp>
         <p:nvSpPr>
-          <p:cNvPr id="25" name="Slide Number Placeholder 0"/>
+          <p:cNvPr id="43" name="Slide Number Placeholder 0"/>
           <p:cNvSpPr>
             <a:spLocks noGrp="1"/>
           </p:cNvSpPr>
@@ -29973,7 +29032,7 @@
       </p:pic>
       <p:sp>
         <p:nvSpPr>
-          <p:cNvPr id="25" name="Slide Number Placeholder 0"/>
+          <p:cNvPr id="64" name="Slide Number Placeholder 0"/>
           <p:cNvSpPr>
             <a:spLocks noGrp="1"/>
           </p:cNvSpPr>
@@ -33658,7 +32717,7 @@
       </p:pic>
       <p:sp>
         <p:nvSpPr>
-          <p:cNvPr id="25" name="Slide Number Placeholder 0"/>
+          <p:cNvPr id="56" name="Slide Number Placeholder 0"/>
           <p:cNvSpPr>
             <a:spLocks noGrp="1"/>
           </p:cNvSpPr>
@@ -36159,7 +35218,7 @@
       </p:pic>
       <p:sp>
         <p:nvSpPr>
-          <p:cNvPr id="25" name="Slide Number Placeholder 0"/>
+          <p:cNvPr id="59" name="Slide Number Placeholder 0"/>
           <p:cNvSpPr>
             <a:spLocks noGrp="1"/>
           </p:cNvSpPr>
@@ -42166,9 +41225,9 @@
           <p:nvPr/>
         </p:nvSpPr>
         <p:spPr>
-          <a:xfrm>
-            <a:off x="10149840" y="4983480"/>
-            <a:ext cx="-548640" cy="0"/>
+          <a:xfrm flipH="1">
+            <a:off x="9601200" y="4983480"/>
+            <a:ext cx="548640" cy="0"/>
           </a:xfrm>
           <a:prstGeom prst="line">
             <a:avLst/>
@@ -42311,7 +41370,7 @@
       </p:pic>
       <p:sp>
         <p:nvSpPr>
-          <p:cNvPr id="25" name="Slide Number Placeholder 0"/>
+          <p:cNvPr id="35" name="Slide Number Placeholder 0"/>
           <p:cNvSpPr>
             <a:spLocks noGrp="1"/>
           </p:cNvSpPr>
@@ -44394,7 +43453,7 @@
       </p:pic>
       <p:sp>
         <p:nvSpPr>
-          <p:cNvPr id="25" name="Slide Number Placeholder 0"/>
+          <p:cNvPr id="37" name="Slide Number Placeholder 0"/>
           <p:cNvSpPr>
             <a:spLocks noGrp="1"/>
           </p:cNvSpPr>
@@ -46193,7 +45252,7 @@
       </p:pic>
       <p:sp>
         <p:nvSpPr>
-          <p:cNvPr id="25" name="Slide Number Placeholder 0"/>
+          <p:cNvPr id="34" name="Slide Number Placeholder 0"/>
           <p:cNvSpPr>
             <a:spLocks noGrp="1"/>
           </p:cNvSpPr>
@@ -47997,7 +47056,7 @@
       </p:pic>
       <p:sp>
         <p:nvSpPr>
-          <p:cNvPr id="25" name="Slide Number Placeholder 0"/>
+          <p:cNvPr id="44" name="Slide Number Placeholder 0"/>
           <p:cNvSpPr>
             <a:spLocks noGrp="1"/>
           </p:cNvSpPr>

</xml_diff>